<commit_message>
docs(presentation): full-bleed title slide, full-height screenshots
Title slide: hero image covers the slide, aspect preserved, right-aligned
so the baked-in logo crops off; readability scrim behind the text column.
Screenshot slides (Why a Control Center, Stdlib, Coupling): images enlarged
to near-full slide height.
</commit_message>
<xml_diff>
--- a/docs/presentations/PFSM_overview.pptx
+++ b/docs/presentations/PFSM_overview.pptx
@@ -3161,2649 +3161,9 @@
           </a:p>
         </p:txBody>
       </p:sp>
-      <p:sp>
-        <p:nvSpPr>
-          <p:cNvPr id="3" name="Oval 2"/>
-          <p:cNvSpPr/>
-          <p:nvPr/>
-        </p:nvSpPr>
-        <p:spPr>
-          <a:xfrm>
-            <a:off x="1738429" y="5716392"/>
-            <a:ext cx="18288" cy="18288"/>
-          </a:xfrm>
-          <a:prstGeom prst="ellipse">
-            <a:avLst/>
-          </a:prstGeom>
-          <a:solidFill>
-            <a:srgbClr val="3A4A78"/>
-          </a:solidFill>
-          <a:ln>
-            <a:noFill/>
-          </a:ln>
-          <a:effectLst/>
-        </p:spPr>
-        <p:style>
-          <a:lnRef idx="1">
-            <a:schemeClr val="accent1"/>
-          </a:lnRef>
-          <a:fillRef idx="3">
-            <a:schemeClr val="accent1"/>
-          </a:fillRef>
-          <a:effectRef idx="2">
-            <a:schemeClr val="accent1"/>
-          </a:effectRef>
-          <a:fontRef idx="minor">
-            <a:schemeClr val="lt1"/>
-          </a:fontRef>
-        </p:style>
-        <p:txBody>
-          <a:bodyPr rtlCol="0" anchor="ctr"/>
-          <a:lstStyle/>
-          <a:p>
-            <a:pPr algn="ctr"/>
-          </a:p>
-        </p:txBody>
-      </p:sp>
-      <p:sp>
-        <p:nvSpPr>
-          <p:cNvPr id="4" name="Oval 3"/>
-          <p:cNvSpPr/>
-          <p:nvPr/>
-        </p:nvSpPr>
-        <p:spPr>
-          <a:xfrm>
-            <a:off x="3176913" y="3398946"/>
-            <a:ext cx="27432" cy="27432"/>
-          </a:xfrm>
-          <a:prstGeom prst="ellipse">
-            <a:avLst/>
-          </a:prstGeom>
-          <a:solidFill>
-            <a:srgbClr val="3A4A78"/>
-          </a:solidFill>
-          <a:ln>
-            <a:noFill/>
-          </a:ln>
-          <a:effectLst/>
-        </p:spPr>
-        <p:style>
-          <a:lnRef idx="1">
-            <a:schemeClr val="accent1"/>
-          </a:lnRef>
-          <a:fillRef idx="3">
-            <a:schemeClr val="accent1"/>
-          </a:fillRef>
-          <a:effectRef idx="2">
-            <a:schemeClr val="accent1"/>
-          </a:effectRef>
-          <a:fontRef idx="minor">
-            <a:schemeClr val="lt1"/>
-          </a:fontRef>
-        </p:style>
-        <p:txBody>
-          <a:bodyPr rtlCol="0" anchor="ctr"/>
-          <a:lstStyle/>
-          <a:p>
-            <a:pPr algn="ctr"/>
-          </a:p>
-        </p:txBody>
-      </p:sp>
-      <p:sp>
-        <p:nvSpPr>
-          <p:cNvPr id="5" name="Oval 4"/>
-          <p:cNvSpPr/>
-          <p:nvPr/>
-        </p:nvSpPr>
-        <p:spPr>
-          <a:xfrm>
-            <a:off x="5765083" y="2636425"/>
-            <a:ext cx="18288" cy="18288"/>
-          </a:xfrm>
-          <a:prstGeom prst="ellipse">
-            <a:avLst/>
-          </a:prstGeom>
-          <a:solidFill>
-            <a:srgbClr val="3A4A78"/>
-          </a:solidFill>
-          <a:ln>
-            <a:noFill/>
-          </a:ln>
-          <a:effectLst/>
-        </p:spPr>
-        <p:style>
-          <a:lnRef idx="1">
-            <a:schemeClr val="accent1"/>
-          </a:lnRef>
-          <a:fillRef idx="3">
-            <a:schemeClr val="accent1"/>
-          </a:fillRef>
-          <a:effectRef idx="2">
-            <a:schemeClr val="accent1"/>
-          </a:effectRef>
-          <a:fontRef idx="minor">
-            <a:schemeClr val="lt1"/>
-          </a:fontRef>
-        </p:style>
-        <p:txBody>
-          <a:bodyPr rtlCol="0" anchor="ctr"/>
-          <a:lstStyle/>
-          <a:p>
-            <a:pPr algn="ctr"/>
-          </a:p>
-        </p:txBody>
-      </p:sp>
-      <p:sp>
-        <p:nvSpPr>
-          <p:cNvPr id="6" name="Oval 5"/>
-          <p:cNvSpPr/>
-          <p:nvPr/>
-        </p:nvSpPr>
-        <p:spPr>
-          <a:xfrm>
-            <a:off x="1255719" y="323790"/>
-            <a:ext cx="27432" cy="27432"/>
-          </a:xfrm>
-          <a:prstGeom prst="ellipse">
-            <a:avLst/>
-          </a:prstGeom>
-          <a:solidFill>
-            <a:srgbClr val="3A4A78"/>
-          </a:solidFill>
-          <a:ln>
-            <a:noFill/>
-          </a:ln>
-          <a:effectLst/>
-        </p:spPr>
-        <p:style>
-          <a:lnRef idx="1">
-            <a:schemeClr val="accent1"/>
-          </a:lnRef>
-          <a:fillRef idx="3">
-            <a:schemeClr val="accent1"/>
-          </a:fillRef>
-          <a:effectRef idx="2">
-            <a:schemeClr val="accent1"/>
-          </a:effectRef>
-          <a:fontRef idx="minor">
-            <a:schemeClr val="lt1"/>
-          </a:fontRef>
-        </p:style>
-        <p:txBody>
-          <a:bodyPr rtlCol="0" anchor="ctr"/>
-          <a:lstStyle/>
-          <a:p>
-            <a:pPr algn="ctr"/>
-          </a:p>
-        </p:txBody>
-      </p:sp>
-      <p:sp>
-        <p:nvSpPr>
-          <p:cNvPr id="7" name="Oval 6"/>
-          <p:cNvSpPr/>
-          <p:nvPr/>
-        </p:nvSpPr>
-        <p:spPr>
-          <a:xfrm>
-            <a:off x="5294607" y="5155768"/>
-            <a:ext cx="18288" cy="18288"/>
-          </a:xfrm>
-          <a:prstGeom prst="ellipse">
-            <a:avLst/>
-          </a:prstGeom>
-          <a:solidFill>
-            <a:srgbClr val="3A4A78"/>
-          </a:solidFill>
-          <a:ln>
-            <a:noFill/>
-          </a:ln>
-          <a:effectLst/>
-        </p:spPr>
-        <p:style>
-          <a:lnRef idx="1">
-            <a:schemeClr val="accent1"/>
-          </a:lnRef>
-          <a:fillRef idx="3">
-            <a:schemeClr val="accent1"/>
-          </a:fillRef>
-          <a:effectRef idx="2">
-            <a:schemeClr val="accent1"/>
-          </a:effectRef>
-          <a:fontRef idx="minor">
-            <a:schemeClr val="lt1"/>
-          </a:fontRef>
-        </p:style>
-        <p:txBody>
-          <a:bodyPr rtlCol="0" anchor="ctr"/>
-          <a:lstStyle/>
-          <a:p>
-            <a:pPr algn="ctr"/>
-          </a:p>
-        </p:txBody>
-      </p:sp>
-      <p:sp>
-        <p:nvSpPr>
-          <p:cNvPr id="8" name="Oval 7"/>
-          <p:cNvSpPr/>
-          <p:nvPr/>
-        </p:nvSpPr>
-        <p:spPr>
-          <a:xfrm>
-            <a:off x="8429661" y="1890595"/>
-            <a:ext cx="18288" cy="18288"/>
-          </a:xfrm>
-          <a:prstGeom prst="ellipse">
-            <a:avLst/>
-          </a:prstGeom>
-          <a:solidFill>
-            <a:srgbClr val="3A4A78"/>
-          </a:solidFill>
-          <a:ln>
-            <a:noFill/>
-          </a:ln>
-          <a:effectLst/>
-        </p:spPr>
-        <p:style>
-          <a:lnRef idx="1">
-            <a:schemeClr val="accent1"/>
-          </a:lnRef>
-          <a:fillRef idx="3">
-            <a:schemeClr val="accent1"/>
-          </a:fillRef>
-          <a:effectRef idx="2">
-            <a:schemeClr val="accent1"/>
-          </a:effectRef>
-          <a:fontRef idx="minor">
-            <a:schemeClr val="lt1"/>
-          </a:fontRef>
-        </p:style>
-        <p:txBody>
-          <a:bodyPr rtlCol="0" anchor="ctr"/>
-          <a:lstStyle/>
-          <a:p>
-            <a:pPr algn="ctr"/>
-          </a:p>
-        </p:txBody>
-      </p:sp>
-      <p:sp>
-        <p:nvSpPr>
-          <p:cNvPr id="9" name="Oval 8"/>
-          <p:cNvSpPr/>
-          <p:nvPr/>
-        </p:nvSpPr>
-        <p:spPr>
-          <a:xfrm>
-            <a:off x="7182157" y="810190"/>
-            <a:ext cx="27432" cy="27432"/>
-          </a:xfrm>
-          <a:prstGeom prst="ellipse">
-            <a:avLst/>
-          </a:prstGeom>
-          <a:solidFill>
-            <a:srgbClr val="3A4A78"/>
-          </a:solidFill>
-          <a:ln>
-            <a:noFill/>
-          </a:ln>
-          <a:effectLst/>
-        </p:spPr>
-        <p:style>
-          <a:lnRef idx="1">
-            <a:schemeClr val="accent1"/>
-          </a:lnRef>
-          <a:fillRef idx="3">
-            <a:schemeClr val="accent1"/>
-          </a:fillRef>
-          <a:effectRef idx="2">
-            <a:schemeClr val="accent1"/>
-          </a:effectRef>
-          <a:fontRef idx="minor">
-            <a:schemeClr val="lt1"/>
-          </a:fontRef>
-        </p:style>
-        <p:txBody>
-          <a:bodyPr rtlCol="0" anchor="ctr"/>
-          <a:lstStyle/>
-          <a:p>
-            <a:pPr algn="ctr"/>
-          </a:p>
-        </p:txBody>
-      </p:sp>
-      <p:sp>
-        <p:nvSpPr>
-          <p:cNvPr id="10" name="Oval 9"/>
-          <p:cNvSpPr/>
-          <p:nvPr/>
-        </p:nvSpPr>
-        <p:spPr>
-          <a:xfrm>
-            <a:off x="501712" y="304687"/>
-            <a:ext cx="41148" cy="41148"/>
-          </a:xfrm>
-          <a:prstGeom prst="ellipse">
-            <a:avLst/>
-          </a:prstGeom>
-          <a:solidFill>
-            <a:srgbClr val="3A4A78"/>
-          </a:solidFill>
-          <a:ln>
-            <a:noFill/>
-          </a:ln>
-          <a:effectLst/>
-        </p:spPr>
-        <p:style>
-          <a:lnRef idx="1">
-            <a:schemeClr val="accent1"/>
-          </a:lnRef>
-          <a:fillRef idx="3">
-            <a:schemeClr val="accent1"/>
-          </a:fillRef>
-          <a:effectRef idx="2">
-            <a:schemeClr val="accent1"/>
-          </a:effectRef>
-          <a:fontRef idx="minor">
-            <a:schemeClr val="lt1"/>
-          </a:fontRef>
-        </p:style>
-        <p:txBody>
-          <a:bodyPr rtlCol="0" anchor="ctr"/>
-          <a:lstStyle/>
-          <a:p>
-            <a:pPr algn="ctr"/>
-          </a:p>
-        </p:txBody>
-      </p:sp>
-      <p:sp>
-        <p:nvSpPr>
-          <p:cNvPr id="11" name="Oval 10"/>
-          <p:cNvSpPr/>
-          <p:nvPr/>
-        </p:nvSpPr>
-        <p:spPr>
-          <a:xfrm>
-            <a:off x="246858" y="5938921"/>
-            <a:ext cx="41148" cy="41148"/>
-          </a:xfrm>
-          <a:prstGeom prst="ellipse">
-            <a:avLst/>
-          </a:prstGeom>
-          <a:solidFill>
-            <a:srgbClr val="3A4A78"/>
-          </a:solidFill>
-          <a:ln>
-            <a:noFill/>
-          </a:ln>
-          <a:effectLst/>
-        </p:spPr>
-        <p:style>
-          <a:lnRef idx="1">
-            <a:schemeClr val="accent1"/>
-          </a:lnRef>
-          <a:fillRef idx="3">
-            <a:schemeClr val="accent1"/>
-          </a:fillRef>
-          <a:effectRef idx="2">
-            <a:schemeClr val="accent1"/>
-          </a:effectRef>
-          <a:fontRef idx="minor">
-            <a:schemeClr val="lt1"/>
-          </a:fontRef>
-        </p:style>
-        <p:txBody>
-          <a:bodyPr rtlCol="0" anchor="ctr"/>
-          <a:lstStyle/>
-          <a:p>
-            <a:pPr algn="ctr"/>
-          </a:p>
-        </p:txBody>
-      </p:sp>
-      <p:sp>
-        <p:nvSpPr>
-          <p:cNvPr id="12" name="Oval 11"/>
-          <p:cNvSpPr/>
-          <p:nvPr/>
-        </p:nvSpPr>
-        <p:spPr>
-          <a:xfrm>
-            <a:off x="2718456" y="2916240"/>
-            <a:ext cx="18288" cy="18288"/>
-          </a:xfrm>
-          <a:prstGeom prst="ellipse">
-            <a:avLst/>
-          </a:prstGeom>
-          <a:solidFill>
-            <a:srgbClr val="3A4A78"/>
-          </a:solidFill>
-          <a:ln>
-            <a:noFill/>
-          </a:ln>
-          <a:effectLst/>
-        </p:spPr>
-        <p:style>
-          <a:lnRef idx="1">
-            <a:schemeClr val="accent1"/>
-          </a:lnRef>
-          <a:fillRef idx="3">
-            <a:schemeClr val="accent1"/>
-          </a:fillRef>
-          <a:effectRef idx="2">
-            <a:schemeClr val="accent1"/>
-          </a:effectRef>
-          <a:fontRef idx="minor">
-            <a:schemeClr val="lt1"/>
-          </a:fontRef>
-        </p:style>
-        <p:txBody>
-          <a:bodyPr rtlCol="0" anchor="ctr"/>
-          <a:lstStyle/>
-          <a:p>
-            <a:pPr algn="ctr"/>
-          </a:p>
-        </p:txBody>
-      </p:sp>
-      <p:sp>
-        <p:nvSpPr>
-          <p:cNvPr id="13" name="Oval 12"/>
-          <p:cNvSpPr/>
-          <p:nvPr/>
-        </p:nvSpPr>
-        <p:spPr>
-          <a:xfrm>
-            <a:off x="6425117" y="5165122"/>
-            <a:ext cx="27432" cy="27432"/>
-          </a:xfrm>
-          <a:prstGeom prst="ellipse">
-            <a:avLst/>
-          </a:prstGeom>
-          <a:solidFill>
-            <a:srgbClr val="3A4A78"/>
-          </a:solidFill>
-          <a:ln>
-            <a:noFill/>
-          </a:ln>
-          <a:effectLst/>
-        </p:spPr>
-        <p:style>
-          <a:lnRef idx="1">
-            <a:schemeClr val="accent1"/>
-          </a:lnRef>
-          <a:fillRef idx="3">
-            <a:schemeClr val="accent1"/>
-          </a:fillRef>
-          <a:effectRef idx="2">
-            <a:schemeClr val="accent1"/>
-          </a:effectRef>
-          <a:fontRef idx="minor">
-            <a:schemeClr val="lt1"/>
-          </a:fontRef>
-        </p:style>
-        <p:txBody>
-          <a:bodyPr rtlCol="0" anchor="ctr"/>
-          <a:lstStyle/>
-          <a:p>
-            <a:pPr algn="ctr"/>
-          </a:p>
-        </p:txBody>
-      </p:sp>
-      <p:sp>
-        <p:nvSpPr>
-          <p:cNvPr id="14" name="Oval 13"/>
-          <p:cNvSpPr/>
-          <p:nvPr/>
-        </p:nvSpPr>
-        <p:spPr>
-          <a:xfrm>
-            <a:off x="6725795" y="2413140"/>
-            <a:ext cx="41148" cy="41148"/>
-          </a:xfrm>
-          <a:prstGeom prst="ellipse">
-            <a:avLst/>
-          </a:prstGeom>
-          <a:solidFill>
-            <a:srgbClr val="3A4A78"/>
-          </a:solidFill>
-          <a:ln>
-            <a:noFill/>
-          </a:ln>
-          <a:effectLst/>
-        </p:spPr>
-        <p:style>
-          <a:lnRef idx="1">
-            <a:schemeClr val="accent1"/>
-          </a:lnRef>
-          <a:fillRef idx="3">
-            <a:schemeClr val="accent1"/>
-          </a:fillRef>
-          <a:effectRef idx="2">
-            <a:schemeClr val="accent1"/>
-          </a:effectRef>
-          <a:fontRef idx="minor">
-            <a:schemeClr val="lt1"/>
-          </a:fontRef>
-        </p:style>
-        <p:txBody>
-          <a:bodyPr rtlCol="0" anchor="ctr"/>
-          <a:lstStyle/>
-          <a:p>
-            <a:pPr algn="ctr"/>
-          </a:p>
-        </p:txBody>
-      </p:sp>
-      <p:sp>
-        <p:nvSpPr>
-          <p:cNvPr id="15" name="Oval 14"/>
-          <p:cNvSpPr/>
-          <p:nvPr/>
-        </p:nvSpPr>
-        <p:spPr>
-          <a:xfrm>
-            <a:off x="2744455" y="3163042"/>
-            <a:ext cx="27432" cy="27432"/>
-          </a:xfrm>
-          <a:prstGeom prst="ellipse">
-            <a:avLst/>
-          </a:prstGeom>
-          <a:solidFill>
-            <a:srgbClr val="3A4A78"/>
-          </a:solidFill>
-          <a:ln>
-            <a:noFill/>
-          </a:ln>
-          <a:effectLst/>
-        </p:spPr>
-        <p:style>
-          <a:lnRef idx="1">
-            <a:schemeClr val="accent1"/>
-          </a:lnRef>
-          <a:fillRef idx="3">
-            <a:schemeClr val="accent1"/>
-          </a:fillRef>
-          <a:effectRef idx="2">
-            <a:schemeClr val="accent1"/>
-          </a:effectRef>
-          <a:fontRef idx="minor">
-            <a:schemeClr val="lt1"/>
-          </a:fontRef>
-        </p:style>
-        <p:txBody>
-          <a:bodyPr rtlCol="0" anchor="ctr"/>
-          <a:lstStyle/>
-          <a:p>
-            <a:pPr algn="ctr"/>
-          </a:p>
-        </p:txBody>
-      </p:sp>
-      <p:sp>
-        <p:nvSpPr>
-          <p:cNvPr id="16" name="Oval 15"/>
-          <p:cNvSpPr/>
-          <p:nvPr/>
-        </p:nvSpPr>
-        <p:spPr>
-          <a:xfrm>
-            <a:off x="11178687" y="2877155"/>
-            <a:ext cx="41148" cy="41148"/>
-          </a:xfrm>
-          <a:prstGeom prst="ellipse">
-            <a:avLst/>
-          </a:prstGeom>
-          <a:solidFill>
-            <a:srgbClr val="3A4A78"/>
-          </a:solidFill>
-          <a:ln>
-            <a:noFill/>
-          </a:ln>
-          <a:effectLst/>
-        </p:spPr>
-        <p:style>
-          <a:lnRef idx="1">
-            <a:schemeClr val="accent1"/>
-          </a:lnRef>
-          <a:fillRef idx="3">
-            <a:schemeClr val="accent1"/>
-          </a:fillRef>
-          <a:effectRef idx="2">
-            <a:schemeClr val="accent1"/>
-          </a:effectRef>
-          <a:fontRef idx="minor">
-            <a:schemeClr val="lt1"/>
-          </a:fontRef>
-        </p:style>
-        <p:txBody>
-          <a:bodyPr rtlCol="0" anchor="ctr"/>
-          <a:lstStyle/>
-          <a:p>
-            <a:pPr algn="ctr"/>
-          </a:p>
-        </p:txBody>
-      </p:sp>
-      <p:sp>
-        <p:nvSpPr>
-          <p:cNvPr id="17" name="Oval 16"/>
-          <p:cNvSpPr/>
-          <p:nvPr/>
-        </p:nvSpPr>
-        <p:spPr>
-          <a:xfrm>
-            <a:off x="11127227" y="795529"/>
-            <a:ext cx="41148" cy="41148"/>
-          </a:xfrm>
-          <a:prstGeom prst="ellipse">
-            <a:avLst/>
-          </a:prstGeom>
-          <a:solidFill>
-            <a:srgbClr val="3A4A78"/>
-          </a:solidFill>
-          <a:ln>
-            <a:noFill/>
-          </a:ln>
-          <a:effectLst/>
-        </p:spPr>
-        <p:style>
-          <a:lnRef idx="1">
-            <a:schemeClr val="accent1"/>
-          </a:lnRef>
-          <a:fillRef idx="3">
-            <a:schemeClr val="accent1"/>
-          </a:fillRef>
-          <a:effectRef idx="2">
-            <a:schemeClr val="accent1"/>
-          </a:effectRef>
-          <a:fontRef idx="minor">
-            <a:schemeClr val="lt1"/>
-          </a:fontRef>
-        </p:style>
-        <p:txBody>
-          <a:bodyPr rtlCol="0" anchor="ctr"/>
-          <a:lstStyle/>
-          <a:p>
-            <a:pPr algn="ctr"/>
-          </a:p>
-        </p:txBody>
-      </p:sp>
-      <p:sp>
-        <p:nvSpPr>
-          <p:cNvPr id="18" name="Oval 17"/>
-          <p:cNvSpPr/>
-          <p:nvPr/>
-        </p:nvSpPr>
-        <p:spPr>
-          <a:xfrm>
-            <a:off x="11965672" y="5798772"/>
-            <a:ext cx="18288" cy="18288"/>
-          </a:xfrm>
-          <a:prstGeom prst="ellipse">
-            <a:avLst/>
-          </a:prstGeom>
-          <a:solidFill>
-            <a:srgbClr val="3A4A78"/>
-          </a:solidFill>
-          <a:ln>
-            <a:noFill/>
-          </a:ln>
-          <a:effectLst/>
-        </p:spPr>
-        <p:style>
-          <a:lnRef idx="1">
-            <a:schemeClr val="accent1"/>
-          </a:lnRef>
-          <a:fillRef idx="3">
-            <a:schemeClr val="accent1"/>
-          </a:fillRef>
-          <a:effectRef idx="2">
-            <a:schemeClr val="accent1"/>
-          </a:effectRef>
-          <a:fontRef idx="minor">
-            <a:schemeClr val="lt1"/>
-          </a:fontRef>
-        </p:style>
-        <p:txBody>
-          <a:bodyPr rtlCol="0" anchor="ctr"/>
-          <a:lstStyle/>
-          <a:p>
-            <a:pPr algn="ctr"/>
-          </a:p>
-        </p:txBody>
-      </p:sp>
-      <p:sp>
-        <p:nvSpPr>
-          <p:cNvPr id="19" name="Oval 18"/>
-          <p:cNvSpPr/>
-          <p:nvPr/>
-        </p:nvSpPr>
-        <p:spPr>
-          <a:xfrm>
-            <a:off x="8993517" y="6033341"/>
-            <a:ext cx="41148" cy="41148"/>
-          </a:xfrm>
-          <a:prstGeom prst="ellipse">
-            <a:avLst/>
-          </a:prstGeom>
-          <a:solidFill>
-            <a:srgbClr val="3A4A78"/>
-          </a:solidFill>
-          <a:ln>
-            <a:noFill/>
-          </a:ln>
-          <a:effectLst/>
-        </p:spPr>
-        <p:style>
-          <a:lnRef idx="1">
-            <a:schemeClr val="accent1"/>
-          </a:lnRef>
-          <a:fillRef idx="3">
-            <a:schemeClr val="accent1"/>
-          </a:fillRef>
-          <a:effectRef idx="2">
-            <a:schemeClr val="accent1"/>
-          </a:effectRef>
-          <a:fontRef idx="minor">
-            <a:schemeClr val="lt1"/>
-          </a:fontRef>
-        </p:style>
-        <p:txBody>
-          <a:bodyPr rtlCol="0" anchor="ctr"/>
-          <a:lstStyle/>
-          <a:p>
-            <a:pPr algn="ctr"/>
-          </a:p>
-        </p:txBody>
-      </p:sp>
-      <p:sp>
-        <p:nvSpPr>
-          <p:cNvPr id="20" name="Oval 19"/>
-          <p:cNvSpPr/>
-          <p:nvPr/>
-        </p:nvSpPr>
-        <p:spPr>
-          <a:xfrm>
-            <a:off x="6105377" y="6504962"/>
-            <a:ext cx="41148" cy="41148"/>
-          </a:xfrm>
-          <a:prstGeom prst="ellipse">
-            <a:avLst/>
-          </a:prstGeom>
-          <a:solidFill>
-            <a:srgbClr val="3A4A78"/>
-          </a:solidFill>
-          <a:ln>
-            <a:noFill/>
-          </a:ln>
-          <a:effectLst/>
-        </p:spPr>
-        <p:style>
-          <a:lnRef idx="1">
-            <a:schemeClr val="accent1"/>
-          </a:lnRef>
-          <a:fillRef idx="3">
-            <a:schemeClr val="accent1"/>
-          </a:fillRef>
-          <a:effectRef idx="2">
-            <a:schemeClr val="accent1"/>
-          </a:effectRef>
-          <a:fontRef idx="minor">
-            <a:schemeClr val="lt1"/>
-          </a:fontRef>
-        </p:style>
-        <p:txBody>
-          <a:bodyPr rtlCol="0" anchor="ctr"/>
-          <a:lstStyle/>
-          <a:p>
-            <a:pPr algn="ctr"/>
-          </a:p>
-        </p:txBody>
-      </p:sp>
-      <p:sp>
-        <p:nvSpPr>
-          <p:cNvPr id="21" name="Oval 20"/>
-          <p:cNvSpPr/>
-          <p:nvPr/>
-        </p:nvSpPr>
-        <p:spPr>
-          <a:xfrm>
-            <a:off x="10029006" y="4550237"/>
-            <a:ext cx="27432" cy="27432"/>
-          </a:xfrm>
-          <a:prstGeom prst="ellipse">
-            <a:avLst/>
-          </a:prstGeom>
-          <a:solidFill>
-            <a:srgbClr val="3A4A78"/>
-          </a:solidFill>
-          <a:ln>
-            <a:noFill/>
-          </a:ln>
-          <a:effectLst/>
-        </p:spPr>
-        <p:style>
-          <a:lnRef idx="1">
-            <a:schemeClr val="accent1"/>
-          </a:lnRef>
-          <a:fillRef idx="3">
-            <a:schemeClr val="accent1"/>
-          </a:fillRef>
-          <a:effectRef idx="2">
-            <a:schemeClr val="accent1"/>
-          </a:effectRef>
-          <a:fontRef idx="minor">
-            <a:schemeClr val="lt1"/>
-          </a:fontRef>
-        </p:style>
-        <p:txBody>
-          <a:bodyPr rtlCol="0" anchor="ctr"/>
-          <a:lstStyle/>
-          <a:p>
-            <a:pPr algn="ctr"/>
-          </a:p>
-        </p:txBody>
-      </p:sp>
-      <p:sp>
-        <p:nvSpPr>
-          <p:cNvPr id="22" name="Oval 21"/>
-          <p:cNvSpPr/>
-          <p:nvPr/>
-        </p:nvSpPr>
-        <p:spPr>
-          <a:xfrm>
-            <a:off x="3523593" y="6546052"/>
-            <a:ext cx="27432" cy="27432"/>
-          </a:xfrm>
-          <a:prstGeom prst="ellipse">
-            <a:avLst/>
-          </a:prstGeom>
-          <a:solidFill>
-            <a:srgbClr val="3A4A78"/>
-          </a:solidFill>
-          <a:ln>
-            <a:noFill/>
-          </a:ln>
-          <a:effectLst/>
-        </p:spPr>
-        <p:style>
-          <a:lnRef idx="1">
-            <a:schemeClr val="accent1"/>
-          </a:lnRef>
-          <a:fillRef idx="3">
-            <a:schemeClr val="accent1"/>
-          </a:fillRef>
-          <a:effectRef idx="2">
-            <a:schemeClr val="accent1"/>
-          </a:effectRef>
-          <a:fontRef idx="minor">
-            <a:schemeClr val="lt1"/>
-          </a:fontRef>
-        </p:style>
-        <p:txBody>
-          <a:bodyPr rtlCol="0" anchor="ctr"/>
-          <a:lstStyle/>
-          <a:p>
-            <a:pPr algn="ctr"/>
-          </a:p>
-        </p:txBody>
-      </p:sp>
-      <p:sp>
-        <p:nvSpPr>
-          <p:cNvPr id="23" name="Oval 22"/>
-          <p:cNvSpPr/>
-          <p:nvPr/>
-        </p:nvSpPr>
-        <p:spPr>
-          <a:xfrm>
-            <a:off x="10221612" y="3463786"/>
-            <a:ext cx="41148" cy="41148"/>
-          </a:xfrm>
-          <a:prstGeom prst="ellipse">
-            <a:avLst/>
-          </a:prstGeom>
-          <a:solidFill>
-            <a:srgbClr val="3A4A78"/>
-          </a:solidFill>
-          <a:ln>
-            <a:noFill/>
-          </a:ln>
-          <a:effectLst/>
-        </p:spPr>
-        <p:style>
-          <a:lnRef idx="1">
-            <a:schemeClr val="accent1"/>
-          </a:lnRef>
-          <a:fillRef idx="3">
-            <a:schemeClr val="accent1"/>
-          </a:fillRef>
-          <a:effectRef idx="2">
-            <a:schemeClr val="accent1"/>
-          </a:effectRef>
-          <a:fontRef idx="minor">
-            <a:schemeClr val="lt1"/>
-          </a:fontRef>
-        </p:style>
-        <p:txBody>
-          <a:bodyPr rtlCol="0" anchor="ctr"/>
-          <a:lstStyle/>
-          <a:p>
-            <a:pPr algn="ctr"/>
-          </a:p>
-        </p:txBody>
-      </p:sp>
-      <p:sp>
-        <p:nvSpPr>
-          <p:cNvPr id="24" name="Oval 23"/>
-          <p:cNvSpPr/>
-          <p:nvPr/>
-        </p:nvSpPr>
-        <p:spPr>
-          <a:xfrm>
-            <a:off x="10306112" y="3298820"/>
-            <a:ext cx="41148" cy="41148"/>
-          </a:xfrm>
-          <a:prstGeom prst="ellipse">
-            <a:avLst/>
-          </a:prstGeom>
-          <a:solidFill>
-            <a:srgbClr val="3A4A78"/>
-          </a:solidFill>
-          <a:ln>
-            <a:noFill/>
-          </a:ln>
-          <a:effectLst/>
-        </p:spPr>
-        <p:style>
-          <a:lnRef idx="1">
-            <a:schemeClr val="accent1"/>
-          </a:lnRef>
-          <a:fillRef idx="3">
-            <a:schemeClr val="accent1"/>
-          </a:fillRef>
-          <a:effectRef idx="2">
-            <a:schemeClr val="accent1"/>
-          </a:effectRef>
-          <a:fontRef idx="minor">
-            <a:schemeClr val="lt1"/>
-          </a:fontRef>
-        </p:style>
-        <p:txBody>
-          <a:bodyPr rtlCol="0" anchor="ctr"/>
-          <a:lstStyle/>
-          <a:p>
-            <a:pPr algn="ctr"/>
-          </a:p>
-        </p:txBody>
-      </p:sp>
-      <p:sp>
-        <p:nvSpPr>
-          <p:cNvPr id="25" name="Oval 24"/>
-          <p:cNvSpPr/>
-          <p:nvPr/>
-        </p:nvSpPr>
-        <p:spPr>
-          <a:xfrm>
-            <a:off x="9640125" y="2864870"/>
-            <a:ext cx="18288" cy="18288"/>
-          </a:xfrm>
-          <a:prstGeom prst="ellipse">
-            <a:avLst/>
-          </a:prstGeom>
-          <a:solidFill>
-            <a:srgbClr val="3A4A78"/>
-          </a:solidFill>
-          <a:ln>
-            <a:noFill/>
-          </a:ln>
-          <a:effectLst/>
-        </p:spPr>
-        <p:style>
-          <a:lnRef idx="1">
-            <a:schemeClr val="accent1"/>
-          </a:lnRef>
-          <a:fillRef idx="3">
-            <a:schemeClr val="accent1"/>
-          </a:fillRef>
-          <a:effectRef idx="2">
-            <a:schemeClr val="accent1"/>
-          </a:effectRef>
-          <a:fontRef idx="minor">
-            <a:schemeClr val="lt1"/>
-          </a:fontRef>
-        </p:style>
-        <p:txBody>
-          <a:bodyPr rtlCol="0" anchor="ctr"/>
-          <a:lstStyle/>
-          <a:p>
-            <a:pPr algn="ctr"/>
-          </a:p>
-        </p:txBody>
-      </p:sp>
-      <p:sp>
-        <p:nvSpPr>
-          <p:cNvPr id="26" name="Oval 25"/>
-          <p:cNvSpPr/>
-          <p:nvPr/>
-        </p:nvSpPr>
-        <p:spPr>
-          <a:xfrm>
-            <a:off x="4512312" y="5948785"/>
-            <a:ext cx="41148" cy="41148"/>
-          </a:xfrm>
-          <a:prstGeom prst="ellipse">
-            <a:avLst/>
-          </a:prstGeom>
-          <a:solidFill>
-            <a:srgbClr val="3A4A78"/>
-          </a:solidFill>
-          <a:ln>
-            <a:noFill/>
-          </a:ln>
-          <a:effectLst/>
-        </p:spPr>
-        <p:style>
-          <a:lnRef idx="1">
-            <a:schemeClr val="accent1"/>
-          </a:lnRef>
-          <a:fillRef idx="3">
-            <a:schemeClr val="accent1"/>
-          </a:fillRef>
-          <a:effectRef idx="2">
-            <a:schemeClr val="accent1"/>
-          </a:effectRef>
-          <a:fontRef idx="minor">
-            <a:schemeClr val="lt1"/>
-          </a:fontRef>
-        </p:style>
-        <p:txBody>
-          <a:bodyPr rtlCol="0" anchor="ctr"/>
-          <a:lstStyle/>
-          <a:p>
-            <a:pPr algn="ctr"/>
-          </a:p>
-        </p:txBody>
-      </p:sp>
-      <p:sp>
-        <p:nvSpPr>
-          <p:cNvPr id="27" name="Oval 26"/>
-          <p:cNvSpPr/>
-          <p:nvPr/>
-        </p:nvSpPr>
-        <p:spPr>
-          <a:xfrm>
-            <a:off x="8934750" y="706434"/>
-            <a:ext cx="41148" cy="41148"/>
-          </a:xfrm>
-          <a:prstGeom prst="ellipse">
-            <a:avLst/>
-          </a:prstGeom>
-          <a:solidFill>
-            <a:srgbClr val="3A4A78"/>
-          </a:solidFill>
-          <a:ln>
-            <a:noFill/>
-          </a:ln>
-          <a:effectLst/>
-        </p:spPr>
-        <p:style>
-          <a:lnRef idx="1">
-            <a:schemeClr val="accent1"/>
-          </a:lnRef>
-          <a:fillRef idx="3">
-            <a:schemeClr val="accent1"/>
-          </a:fillRef>
-          <a:effectRef idx="2">
-            <a:schemeClr val="accent1"/>
-          </a:effectRef>
-          <a:fontRef idx="minor">
-            <a:schemeClr val="lt1"/>
-          </a:fontRef>
-        </p:style>
-        <p:txBody>
-          <a:bodyPr rtlCol="0" anchor="ctr"/>
-          <a:lstStyle/>
-          <a:p>
-            <a:pPr algn="ctr"/>
-          </a:p>
-        </p:txBody>
-      </p:sp>
-      <p:sp>
-        <p:nvSpPr>
-          <p:cNvPr id="28" name="Oval 27"/>
-          <p:cNvSpPr/>
-          <p:nvPr/>
-        </p:nvSpPr>
-        <p:spPr>
-          <a:xfrm>
-            <a:off x="6196269" y="5262177"/>
-            <a:ext cx="41148" cy="41148"/>
-          </a:xfrm>
-          <a:prstGeom prst="ellipse">
-            <a:avLst/>
-          </a:prstGeom>
-          <a:solidFill>
-            <a:srgbClr val="3A4A78"/>
-          </a:solidFill>
-          <a:ln>
-            <a:noFill/>
-          </a:ln>
-          <a:effectLst/>
-        </p:spPr>
-        <p:style>
-          <a:lnRef idx="1">
-            <a:schemeClr val="accent1"/>
-          </a:lnRef>
-          <a:fillRef idx="3">
-            <a:schemeClr val="accent1"/>
-          </a:fillRef>
-          <a:effectRef idx="2">
-            <a:schemeClr val="accent1"/>
-          </a:effectRef>
-          <a:fontRef idx="minor">
-            <a:schemeClr val="lt1"/>
-          </a:fontRef>
-        </p:style>
-        <p:txBody>
-          <a:bodyPr rtlCol="0" anchor="ctr"/>
-          <a:lstStyle/>
-          <a:p>
-            <a:pPr algn="ctr"/>
-          </a:p>
-        </p:txBody>
-      </p:sp>
-      <p:sp>
-        <p:nvSpPr>
-          <p:cNvPr id="29" name="Oval 28"/>
-          <p:cNvSpPr/>
-          <p:nvPr/>
-        </p:nvSpPr>
-        <p:spPr>
-          <a:xfrm>
-            <a:off x="10147177" y="2576562"/>
-            <a:ext cx="41148" cy="41148"/>
-          </a:xfrm>
-          <a:prstGeom prst="ellipse">
-            <a:avLst/>
-          </a:prstGeom>
-          <a:solidFill>
-            <a:srgbClr val="3A4A78"/>
-          </a:solidFill>
-          <a:ln>
-            <a:noFill/>
-          </a:ln>
-          <a:effectLst/>
-        </p:spPr>
-        <p:style>
-          <a:lnRef idx="1">
-            <a:schemeClr val="accent1"/>
-          </a:lnRef>
-          <a:fillRef idx="3">
-            <a:schemeClr val="accent1"/>
-          </a:fillRef>
-          <a:effectRef idx="2">
-            <a:schemeClr val="accent1"/>
-          </a:effectRef>
-          <a:fontRef idx="minor">
-            <a:schemeClr val="lt1"/>
-          </a:fontRef>
-        </p:style>
-        <p:txBody>
-          <a:bodyPr rtlCol="0" anchor="ctr"/>
-          <a:lstStyle/>
-          <a:p>
-            <a:pPr algn="ctr"/>
-          </a:p>
-        </p:txBody>
-      </p:sp>
-      <p:sp>
-        <p:nvSpPr>
-          <p:cNvPr id="30" name="Oval 29"/>
-          <p:cNvSpPr/>
-          <p:nvPr/>
-        </p:nvSpPr>
-        <p:spPr>
-          <a:xfrm>
-            <a:off x="489615" y="423466"/>
-            <a:ext cx="41148" cy="41148"/>
-          </a:xfrm>
-          <a:prstGeom prst="ellipse">
-            <a:avLst/>
-          </a:prstGeom>
-          <a:solidFill>
-            <a:srgbClr val="3A4A78"/>
-          </a:solidFill>
-          <a:ln>
-            <a:noFill/>
-          </a:ln>
-          <a:effectLst/>
-        </p:spPr>
-        <p:style>
-          <a:lnRef idx="1">
-            <a:schemeClr val="accent1"/>
-          </a:lnRef>
-          <a:fillRef idx="3">
-            <a:schemeClr val="accent1"/>
-          </a:fillRef>
-          <a:effectRef idx="2">
-            <a:schemeClr val="accent1"/>
-          </a:effectRef>
-          <a:fontRef idx="minor">
-            <a:schemeClr val="lt1"/>
-          </a:fontRef>
-        </p:style>
-        <p:txBody>
-          <a:bodyPr rtlCol="0" anchor="ctr"/>
-          <a:lstStyle/>
-          <a:p>
-            <a:pPr algn="ctr"/>
-          </a:p>
-        </p:txBody>
-      </p:sp>
-      <p:sp>
-        <p:nvSpPr>
-          <p:cNvPr id="31" name="Oval 30"/>
-          <p:cNvSpPr/>
-          <p:nvPr/>
-        </p:nvSpPr>
-        <p:spPr>
-          <a:xfrm>
-            <a:off x="10246688" y="4184877"/>
-            <a:ext cx="41148" cy="41148"/>
-          </a:xfrm>
-          <a:prstGeom prst="ellipse">
-            <a:avLst/>
-          </a:prstGeom>
-          <a:solidFill>
-            <a:srgbClr val="3A4A78"/>
-          </a:solidFill>
-          <a:ln>
-            <a:noFill/>
-          </a:ln>
-          <a:effectLst/>
-        </p:spPr>
-        <p:style>
-          <a:lnRef idx="1">
-            <a:schemeClr val="accent1"/>
-          </a:lnRef>
-          <a:fillRef idx="3">
-            <a:schemeClr val="accent1"/>
-          </a:fillRef>
-          <a:effectRef idx="2">
-            <a:schemeClr val="accent1"/>
-          </a:effectRef>
-          <a:fontRef idx="minor">
-            <a:schemeClr val="lt1"/>
-          </a:fontRef>
-        </p:style>
-        <p:txBody>
-          <a:bodyPr rtlCol="0" anchor="ctr"/>
-          <a:lstStyle/>
-          <a:p>
-            <a:pPr algn="ctr"/>
-          </a:p>
-        </p:txBody>
-      </p:sp>
-      <p:sp>
-        <p:nvSpPr>
-          <p:cNvPr id="32" name="Oval 31"/>
-          <p:cNvSpPr/>
-          <p:nvPr/>
-        </p:nvSpPr>
-        <p:spPr>
-          <a:xfrm>
-            <a:off x="4827835" y="1258684"/>
-            <a:ext cx="41148" cy="41148"/>
-          </a:xfrm>
-          <a:prstGeom prst="ellipse">
-            <a:avLst/>
-          </a:prstGeom>
-          <a:solidFill>
-            <a:srgbClr val="3A4A78"/>
-          </a:solidFill>
-          <a:ln>
-            <a:noFill/>
-          </a:ln>
-          <a:effectLst/>
-        </p:spPr>
-        <p:style>
-          <a:lnRef idx="1">
-            <a:schemeClr val="accent1"/>
-          </a:lnRef>
-          <a:fillRef idx="3">
-            <a:schemeClr val="accent1"/>
-          </a:fillRef>
-          <a:effectRef idx="2">
-            <a:schemeClr val="accent1"/>
-          </a:effectRef>
-          <a:fontRef idx="minor">
-            <a:schemeClr val="lt1"/>
-          </a:fontRef>
-        </p:style>
-        <p:txBody>
-          <a:bodyPr rtlCol="0" anchor="ctr"/>
-          <a:lstStyle/>
-          <a:p>
-            <a:pPr algn="ctr"/>
-          </a:p>
-        </p:txBody>
-      </p:sp>
-      <p:sp>
-        <p:nvSpPr>
-          <p:cNvPr id="33" name="Oval 32"/>
-          <p:cNvSpPr/>
-          <p:nvPr/>
-        </p:nvSpPr>
-        <p:spPr>
-          <a:xfrm>
-            <a:off x="2841657" y="218149"/>
-            <a:ext cx="18288" cy="18288"/>
-          </a:xfrm>
-          <a:prstGeom prst="ellipse">
-            <a:avLst/>
-          </a:prstGeom>
-          <a:solidFill>
-            <a:srgbClr val="3A4A78"/>
-          </a:solidFill>
-          <a:ln>
-            <a:noFill/>
-          </a:ln>
-          <a:effectLst/>
-        </p:spPr>
-        <p:style>
-          <a:lnRef idx="1">
-            <a:schemeClr val="accent1"/>
-          </a:lnRef>
-          <a:fillRef idx="3">
-            <a:schemeClr val="accent1"/>
-          </a:fillRef>
-          <a:effectRef idx="2">
-            <a:schemeClr val="accent1"/>
-          </a:effectRef>
-          <a:fontRef idx="minor">
-            <a:schemeClr val="lt1"/>
-          </a:fontRef>
-        </p:style>
-        <p:txBody>
-          <a:bodyPr rtlCol="0" anchor="ctr"/>
-          <a:lstStyle/>
-          <a:p>
-            <a:pPr algn="ctr"/>
-          </a:p>
-        </p:txBody>
-      </p:sp>
-      <p:sp>
-        <p:nvSpPr>
-          <p:cNvPr id="34" name="Oval 33"/>
-          <p:cNvSpPr/>
-          <p:nvPr/>
-        </p:nvSpPr>
-        <p:spPr>
-          <a:xfrm>
-            <a:off x="6567983" y="5801032"/>
-            <a:ext cx="18288" cy="18288"/>
-          </a:xfrm>
-          <a:prstGeom prst="ellipse">
-            <a:avLst/>
-          </a:prstGeom>
-          <a:solidFill>
-            <a:srgbClr val="3A4A78"/>
-          </a:solidFill>
-          <a:ln>
-            <a:noFill/>
-          </a:ln>
-          <a:effectLst/>
-        </p:spPr>
-        <p:style>
-          <a:lnRef idx="1">
-            <a:schemeClr val="accent1"/>
-          </a:lnRef>
-          <a:fillRef idx="3">
-            <a:schemeClr val="accent1"/>
-          </a:fillRef>
-          <a:effectRef idx="2">
-            <a:schemeClr val="accent1"/>
-          </a:effectRef>
-          <a:fontRef idx="minor">
-            <a:schemeClr val="lt1"/>
-          </a:fontRef>
-        </p:style>
-        <p:txBody>
-          <a:bodyPr rtlCol="0" anchor="ctr"/>
-          <a:lstStyle/>
-          <a:p>
-            <a:pPr algn="ctr"/>
-          </a:p>
-        </p:txBody>
-      </p:sp>
-      <p:sp>
-        <p:nvSpPr>
-          <p:cNvPr id="35" name="Oval 34"/>
-          <p:cNvSpPr/>
-          <p:nvPr/>
-        </p:nvSpPr>
-        <p:spPr>
-          <a:xfrm>
-            <a:off x="4957200" y="2400799"/>
-            <a:ext cx="41148" cy="41148"/>
-          </a:xfrm>
-          <a:prstGeom prst="ellipse">
-            <a:avLst/>
-          </a:prstGeom>
-          <a:solidFill>
-            <a:srgbClr val="3A4A78"/>
-          </a:solidFill>
-          <a:ln>
-            <a:noFill/>
-          </a:ln>
-          <a:effectLst/>
-        </p:spPr>
-        <p:style>
-          <a:lnRef idx="1">
-            <a:schemeClr val="accent1"/>
-          </a:lnRef>
-          <a:fillRef idx="3">
-            <a:schemeClr val="accent1"/>
-          </a:fillRef>
-          <a:effectRef idx="2">
-            <a:schemeClr val="accent1"/>
-          </a:effectRef>
-          <a:fontRef idx="minor">
-            <a:schemeClr val="lt1"/>
-          </a:fontRef>
-        </p:style>
-        <p:txBody>
-          <a:bodyPr rtlCol="0" anchor="ctr"/>
-          <a:lstStyle/>
-          <a:p>
-            <a:pPr algn="ctr"/>
-          </a:p>
-        </p:txBody>
-      </p:sp>
-      <p:sp>
-        <p:nvSpPr>
-          <p:cNvPr id="36" name="Oval 35"/>
-          <p:cNvSpPr/>
-          <p:nvPr/>
-        </p:nvSpPr>
-        <p:spPr>
-          <a:xfrm>
-            <a:off x="4347260" y="6126695"/>
-            <a:ext cx="41148" cy="41148"/>
-          </a:xfrm>
-          <a:prstGeom prst="ellipse">
-            <a:avLst/>
-          </a:prstGeom>
-          <a:solidFill>
-            <a:srgbClr val="3A4A78"/>
-          </a:solidFill>
-          <a:ln>
-            <a:noFill/>
-          </a:ln>
-          <a:effectLst/>
-        </p:spPr>
-        <p:style>
-          <a:lnRef idx="1">
-            <a:schemeClr val="accent1"/>
-          </a:lnRef>
-          <a:fillRef idx="3">
-            <a:schemeClr val="accent1"/>
-          </a:fillRef>
-          <a:effectRef idx="2">
-            <a:schemeClr val="accent1"/>
-          </a:effectRef>
-          <a:fontRef idx="minor">
-            <a:schemeClr val="lt1"/>
-          </a:fontRef>
-        </p:style>
-        <p:txBody>
-          <a:bodyPr rtlCol="0" anchor="ctr"/>
-          <a:lstStyle/>
-          <a:p>
-            <a:pPr algn="ctr"/>
-          </a:p>
-        </p:txBody>
-      </p:sp>
-      <p:sp>
-        <p:nvSpPr>
-          <p:cNvPr id="37" name="Oval 36"/>
-          <p:cNvSpPr/>
-          <p:nvPr/>
-        </p:nvSpPr>
-        <p:spPr>
-          <a:xfrm>
-            <a:off x="6667837" y="6438507"/>
-            <a:ext cx="18288" cy="18288"/>
-          </a:xfrm>
-          <a:prstGeom prst="ellipse">
-            <a:avLst/>
-          </a:prstGeom>
-          <a:solidFill>
-            <a:srgbClr val="3A4A78"/>
-          </a:solidFill>
-          <a:ln>
-            <a:noFill/>
-          </a:ln>
-          <a:effectLst/>
-        </p:spPr>
-        <p:style>
-          <a:lnRef idx="1">
-            <a:schemeClr val="accent1"/>
-          </a:lnRef>
-          <a:fillRef idx="3">
-            <a:schemeClr val="accent1"/>
-          </a:fillRef>
-          <a:effectRef idx="2">
-            <a:schemeClr val="accent1"/>
-          </a:effectRef>
-          <a:fontRef idx="minor">
-            <a:schemeClr val="lt1"/>
-          </a:fontRef>
-        </p:style>
-        <p:txBody>
-          <a:bodyPr rtlCol="0" anchor="ctr"/>
-          <a:lstStyle/>
-          <a:p>
-            <a:pPr algn="ctr"/>
-          </a:p>
-        </p:txBody>
-      </p:sp>
-      <p:sp>
-        <p:nvSpPr>
-          <p:cNvPr id="38" name="Oval 37"/>
-          <p:cNvSpPr/>
-          <p:nvPr/>
-        </p:nvSpPr>
-        <p:spPr>
-          <a:xfrm>
-            <a:off x="4709733" y="5779038"/>
-            <a:ext cx="41148" cy="41148"/>
-          </a:xfrm>
-          <a:prstGeom prst="ellipse">
-            <a:avLst/>
-          </a:prstGeom>
-          <a:solidFill>
-            <a:srgbClr val="3A4A78"/>
-          </a:solidFill>
-          <a:ln>
-            <a:noFill/>
-          </a:ln>
-          <a:effectLst/>
-        </p:spPr>
-        <p:style>
-          <a:lnRef idx="1">
-            <a:schemeClr val="accent1"/>
-          </a:lnRef>
-          <a:fillRef idx="3">
-            <a:schemeClr val="accent1"/>
-          </a:fillRef>
-          <a:effectRef idx="2">
-            <a:schemeClr val="accent1"/>
-          </a:effectRef>
-          <a:fontRef idx="minor">
-            <a:schemeClr val="lt1"/>
-          </a:fontRef>
-        </p:style>
-        <p:txBody>
-          <a:bodyPr rtlCol="0" anchor="ctr"/>
-          <a:lstStyle/>
-          <a:p>
-            <a:pPr algn="ctr"/>
-          </a:p>
-        </p:txBody>
-      </p:sp>
-      <p:sp>
-        <p:nvSpPr>
-          <p:cNvPr id="39" name="Oval 38"/>
-          <p:cNvSpPr/>
-          <p:nvPr/>
-        </p:nvSpPr>
-        <p:spPr>
-          <a:xfrm>
-            <a:off x="6244814" y="988096"/>
-            <a:ext cx="41148" cy="41148"/>
-          </a:xfrm>
-          <a:prstGeom prst="ellipse">
-            <a:avLst/>
-          </a:prstGeom>
-          <a:solidFill>
-            <a:srgbClr val="3A4A78"/>
-          </a:solidFill>
-          <a:ln>
-            <a:noFill/>
-          </a:ln>
-          <a:effectLst/>
-        </p:spPr>
-        <p:style>
-          <a:lnRef idx="1">
-            <a:schemeClr val="accent1"/>
-          </a:lnRef>
-          <a:fillRef idx="3">
-            <a:schemeClr val="accent1"/>
-          </a:fillRef>
-          <a:effectRef idx="2">
-            <a:schemeClr val="accent1"/>
-          </a:effectRef>
-          <a:fontRef idx="minor">
-            <a:schemeClr val="lt1"/>
-          </a:fontRef>
-        </p:style>
-        <p:txBody>
-          <a:bodyPr rtlCol="0" anchor="ctr"/>
-          <a:lstStyle/>
-          <a:p>
-            <a:pPr algn="ctr"/>
-          </a:p>
-        </p:txBody>
-      </p:sp>
-      <p:sp>
-        <p:nvSpPr>
-          <p:cNvPr id="40" name="Oval 39"/>
-          <p:cNvSpPr/>
-          <p:nvPr/>
-        </p:nvSpPr>
-        <p:spPr>
-          <a:xfrm>
-            <a:off x="2586004" y="6389807"/>
-            <a:ext cx="27432" cy="27432"/>
-          </a:xfrm>
-          <a:prstGeom prst="ellipse">
-            <a:avLst/>
-          </a:prstGeom>
-          <a:solidFill>
-            <a:srgbClr val="3A4A78"/>
-          </a:solidFill>
-          <a:ln>
-            <a:noFill/>
-          </a:ln>
-          <a:effectLst/>
-        </p:spPr>
-        <p:style>
-          <a:lnRef idx="1">
-            <a:schemeClr val="accent1"/>
-          </a:lnRef>
-          <a:fillRef idx="3">
-            <a:schemeClr val="accent1"/>
-          </a:fillRef>
-          <a:effectRef idx="2">
-            <a:schemeClr val="accent1"/>
-          </a:effectRef>
-          <a:fontRef idx="minor">
-            <a:schemeClr val="lt1"/>
-          </a:fontRef>
-        </p:style>
-        <p:txBody>
-          <a:bodyPr rtlCol="0" anchor="ctr"/>
-          <a:lstStyle/>
-          <a:p>
-            <a:pPr algn="ctr"/>
-          </a:p>
-        </p:txBody>
-      </p:sp>
-      <p:sp>
-        <p:nvSpPr>
-          <p:cNvPr id="41" name="Oval 40"/>
-          <p:cNvSpPr/>
-          <p:nvPr/>
-        </p:nvSpPr>
-        <p:spPr>
-          <a:xfrm>
-            <a:off x="10505397" y="3889853"/>
-            <a:ext cx="18288" cy="18288"/>
-          </a:xfrm>
-          <a:prstGeom prst="ellipse">
-            <a:avLst/>
-          </a:prstGeom>
-          <a:solidFill>
-            <a:srgbClr val="3A4A78"/>
-          </a:solidFill>
-          <a:ln>
-            <a:noFill/>
-          </a:ln>
-          <a:effectLst/>
-        </p:spPr>
-        <p:style>
-          <a:lnRef idx="1">
-            <a:schemeClr val="accent1"/>
-          </a:lnRef>
-          <a:fillRef idx="3">
-            <a:schemeClr val="accent1"/>
-          </a:fillRef>
-          <a:effectRef idx="2">
-            <a:schemeClr val="accent1"/>
-          </a:effectRef>
-          <a:fontRef idx="minor">
-            <a:schemeClr val="lt1"/>
-          </a:fontRef>
-        </p:style>
-        <p:txBody>
-          <a:bodyPr rtlCol="0" anchor="ctr"/>
-          <a:lstStyle/>
-          <a:p>
-            <a:pPr algn="ctr"/>
-          </a:p>
-        </p:txBody>
-      </p:sp>
-      <p:sp>
-        <p:nvSpPr>
-          <p:cNvPr id="42" name="Oval 41"/>
-          <p:cNvSpPr/>
-          <p:nvPr/>
-        </p:nvSpPr>
-        <p:spPr>
-          <a:xfrm>
-            <a:off x="11351571" y="2858853"/>
-            <a:ext cx="27432" cy="27432"/>
-          </a:xfrm>
-          <a:prstGeom prst="ellipse">
-            <a:avLst/>
-          </a:prstGeom>
-          <a:solidFill>
-            <a:srgbClr val="3A4A78"/>
-          </a:solidFill>
-          <a:ln>
-            <a:noFill/>
-          </a:ln>
-          <a:effectLst/>
-        </p:spPr>
-        <p:style>
-          <a:lnRef idx="1">
-            <a:schemeClr val="accent1"/>
-          </a:lnRef>
-          <a:fillRef idx="3">
-            <a:schemeClr val="accent1"/>
-          </a:fillRef>
-          <a:effectRef idx="2">
-            <a:schemeClr val="accent1"/>
-          </a:effectRef>
-          <a:fontRef idx="minor">
-            <a:schemeClr val="lt1"/>
-          </a:fontRef>
-        </p:style>
-        <p:txBody>
-          <a:bodyPr rtlCol="0" anchor="ctr"/>
-          <a:lstStyle/>
-          <a:p>
-            <a:pPr algn="ctr"/>
-          </a:p>
-        </p:txBody>
-      </p:sp>
-      <p:sp>
-        <p:nvSpPr>
-          <p:cNvPr id="43" name="Oval 42"/>
-          <p:cNvSpPr/>
-          <p:nvPr/>
-        </p:nvSpPr>
-        <p:spPr>
-          <a:xfrm>
-            <a:off x="5076012" y="147593"/>
-            <a:ext cx="41148" cy="41148"/>
-          </a:xfrm>
-          <a:prstGeom prst="ellipse">
-            <a:avLst/>
-          </a:prstGeom>
-          <a:solidFill>
-            <a:srgbClr val="3A4A78"/>
-          </a:solidFill>
-          <a:ln>
-            <a:noFill/>
-          </a:ln>
-          <a:effectLst/>
-        </p:spPr>
-        <p:style>
-          <a:lnRef idx="1">
-            <a:schemeClr val="accent1"/>
-          </a:lnRef>
-          <a:fillRef idx="3">
-            <a:schemeClr val="accent1"/>
-          </a:fillRef>
-          <a:effectRef idx="2">
-            <a:schemeClr val="accent1"/>
-          </a:effectRef>
-          <a:fontRef idx="minor">
-            <a:schemeClr val="lt1"/>
-          </a:fontRef>
-        </p:style>
-        <p:txBody>
-          <a:bodyPr rtlCol="0" anchor="ctr"/>
-          <a:lstStyle/>
-          <a:p>
-            <a:pPr algn="ctr"/>
-          </a:p>
-        </p:txBody>
-      </p:sp>
-      <p:sp>
-        <p:nvSpPr>
-          <p:cNvPr id="44" name="Oval 43"/>
-          <p:cNvSpPr/>
-          <p:nvPr/>
-        </p:nvSpPr>
-        <p:spPr>
-          <a:xfrm>
-            <a:off x="7567517" y="4169351"/>
-            <a:ext cx="27432" cy="27432"/>
-          </a:xfrm>
-          <a:prstGeom prst="ellipse">
-            <a:avLst/>
-          </a:prstGeom>
-          <a:solidFill>
-            <a:srgbClr val="3A4A78"/>
-          </a:solidFill>
-          <a:ln>
-            <a:noFill/>
-          </a:ln>
-          <a:effectLst/>
-        </p:spPr>
-        <p:style>
-          <a:lnRef idx="1">
-            <a:schemeClr val="accent1"/>
-          </a:lnRef>
-          <a:fillRef idx="3">
-            <a:schemeClr val="accent1"/>
-          </a:fillRef>
-          <a:effectRef idx="2">
-            <a:schemeClr val="accent1"/>
-          </a:effectRef>
-          <a:fontRef idx="minor">
-            <a:schemeClr val="lt1"/>
-          </a:fontRef>
-        </p:style>
-        <p:txBody>
-          <a:bodyPr rtlCol="0" anchor="ctr"/>
-          <a:lstStyle/>
-          <a:p>
-            <a:pPr algn="ctr"/>
-          </a:p>
-        </p:txBody>
-      </p:sp>
-      <p:sp>
-        <p:nvSpPr>
-          <p:cNvPr id="45" name="Oval 44"/>
-          <p:cNvSpPr/>
-          <p:nvPr/>
-        </p:nvSpPr>
-        <p:spPr>
-          <a:xfrm>
-            <a:off x="7285859" y="5434188"/>
-            <a:ext cx="41148" cy="41148"/>
-          </a:xfrm>
-          <a:prstGeom prst="ellipse">
-            <a:avLst/>
-          </a:prstGeom>
-          <a:solidFill>
-            <a:srgbClr val="3A4A78"/>
-          </a:solidFill>
-          <a:ln>
-            <a:noFill/>
-          </a:ln>
-          <a:effectLst/>
-        </p:spPr>
-        <p:style>
-          <a:lnRef idx="1">
-            <a:schemeClr val="accent1"/>
-          </a:lnRef>
-          <a:fillRef idx="3">
-            <a:schemeClr val="accent1"/>
-          </a:fillRef>
-          <a:effectRef idx="2">
-            <a:schemeClr val="accent1"/>
-          </a:effectRef>
-          <a:fontRef idx="minor">
-            <a:schemeClr val="lt1"/>
-          </a:fontRef>
-        </p:style>
-        <p:txBody>
-          <a:bodyPr rtlCol="0" anchor="ctr"/>
-          <a:lstStyle/>
-          <a:p>
-            <a:pPr algn="ctr"/>
-          </a:p>
-        </p:txBody>
-      </p:sp>
-      <p:sp>
-        <p:nvSpPr>
-          <p:cNvPr id="46" name="Oval 45"/>
-          <p:cNvSpPr/>
-          <p:nvPr/>
-        </p:nvSpPr>
-        <p:spPr>
-          <a:xfrm>
-            <a:off x="2249053" y="3985063"/>
-            <a:ext cx="18288" cy="18288"/>
-          </a:xfrm>
-          <a:prstGeom prst="ellipse">
-            <a:avLst/>
-          </a:prstGeom>
-          <a:solidFill>
-            <a:srgbClr val="3A4A78"/>
-          </a:solidFill>
-          <a:ln>
-            <a:noFill/>
-          </a:ln>
-          <a:effectLst/>
-        </p:spPr>
-        <p:style>
-          <a:lnRef idx="1">
-            <a:schemeClr val="accent1"/>
-          </a:lnRef>
-          <a:fillRef idx="3">
-            <a:schemeClr val="accent1"/>
-          </a:fillRef>
-          <a:effectRef idx="2">
-            <a:schemeClr val="accent1"/>
-          </a:effectRef>
-          <a:fontRef idx="minor">
-            <a:schemeClr val="lt1"/>
-          </a:fontRef>
-        </p:style>
-        <p:txBody>
-          <a:bodyPr rtlCol="0" anchor="ctr"/>
-          <a:lstStyle/>
-          <a:p>
-            <a:pPr algn="ctr"/>
-          </a:p>
-        </p:txBody>
-      </p:sp>
-      <p:sp>
-        <p:nvSpPr>
-          <p:cNvPr id="47" name="Oval 46"/>
-          <p:cNvSpPr/>
-          <p:nvPr/>
-        </p:nvSpPr>
-        <p:spPr>
-          <a:xfrm>
-            <a:off x="9652456" y="5384995"/>
-            <a:ext cx="27432" cy="27432"/>
-          </a:xfrm>
-          <a:prstGeom prst="ellipse">
-            <a:avLst/>
-          </a:prstGeom>
-          <a:solidFill>
-            <a:srgbClr val="3A4A78"/>
-          </a:solidFill>
-          <a:ln>
-            <a:noFill/>
-          </a:ln>
-          <a:effectLst/>
-        </p:spPr>
-        <p:style>
-          <a:lnRef idx="1">
-            <a:schemeClr val="accent1"/>
-          </a:lnRef>
-          <a:fillRef idx="3">
-            <a:schemeClr val="accent1"/>
-          </a:fillRef>
-          <a:effectRef idx="2">
-            <a:schemeClr val="accent1"/>
-          </a:effectRef>
-          <a:fontRef idx="minor">
-            <a:schemeClr val="lt1"/>
-          </a:fontRef>
-        </p:style>
-        <p:txBody>
-          <a:bodyPr rtlCol="0" anchor="ctr"/>
-          <a:lstStyle/>
-          <a:p>
-            <a:pPr algn="ctr"/>
-          </a:p>
-        </p:txBody>
-      </p:sp>
-      <p:sp>
-        <p:nvSpPr>
-          <p:cNvPr id="48" name="Oval 47"/>
-          <p:cNvSpPr/>
-          <p:nvPr/>
-        </p:nvSpPr>
-        <p:spPr>
-          <a:xfrm>
-            <a:off x="523987" y="6349324"/>
-            <a:ext cx="18288" cy="18288"/>
-          </a:xfrm>
-          <a:prstGeom prst="ellipse">
-            <a:avLst/>
-          </a:prstGeom>
-          <a:solidFill>
-            <a:srgbClr val="3A4A78"/>
-          </a:solidFill>
-          <a:ln>
-            <a:noFill/>
-          </a:ln>
-          <a:effectLst/>
-        </p:spPr>
-        <p:style>
-          <a:lnRef idx="1">
-            <a:schemeClr val="accent1"/>
-          </a:lnRef>
-          <a:fillRef idx="3">
-            <a:schemeClr val="accent1"/>
-          </a:fillRef>
-          <a:effectRef idx="2">
-            <a:schemeClr val="accent1"/>
-          </a:effectRef>
-          <a:fontRef idx="minor">
-            <a:schemeClr val="lt1"/>
-          </a:fontRef>
-        </p:style>
-        <p:txBody>
-          <a:bodyPr rtlCol="0" anchor="ctr"/>
-          <a:lstStyle/>
-          <a:p>
-            <a:pPr algn="ctr"/>
-          </a:p>
-        </p:txBody>
-      </p:sp>
-      <p:sp>
-        <p:nvSpPr>
-          <p:cNvPr id="49" name="Oval 48"/>
-          <p:cNvSpPr/>
-          <p:nvPr/>
-        </p:nvSpPr>
-        <p:spPr>
-          <a:xfrm>
-            <a:off x="1129092" y="247045"/>
-            <a:ext cx="18288" cy="18288"/>
-          </a:xfrm>
-          <a:prstGeom prst="ellipse">
-            <a:avLst/>
-          </a:prstGeom>
-          <a:solidFill>
-            <a:srgbClr val="3A4A78"/>
-          </a:solidFill>
-          <a:ln>
-            <a:noFill/>
-          </a:ln>
-          <a:effectLst/>
-        </p:spPr>
-        <p:style>
-          <a:lnRef idx="1">
-            <a:schemeClr val="accent1"/>
-          </a:lnRef>
-          <a:fillRef idx="3">
-            <a:schemeClr val="accent1"/>
-          </a:fillRef>
-          <a:effectRef idx="2">
-            <a:schemeClr val="accent1"/>
-          </a:effectRef>
-          <a:fontRef idx="minor">
-            <a:schemeClr val="lt1"/>
-          </a:fontRef>
-        </p:style>
-        <p:txBody>
-          <a:bodyPr rtlCol="0" anchor="ctr"/>
-          <a:lstStyle/>
-          <a:p>
-            <a:pPr algn="ctr"/>
-          </a:p>
-        </p:txBody>
-      </p:sp>
-      <p:sp>
-        <p:nvSpPr>
-          <p:cNvPr id="50" name="Oval 49"/>
-          <p:cNvSpPr/>
-          <p:nvPr/>
-        </p:nvSpPr>
-        <p:spPr>
-          <a:xfrm>
-            <a:off x="9124592" y="1988468"/>
-            <a:ext cx="27432" cy="27432"/>
-          </a:xfrm>
-          <a:prstGeom prst="ellipse">
-            <a:avLst/>
-          </a:prstGeom>
-          <a:solidFill>
-            <a:srgbClr val="3A4A78"/>
-          </a:solidFill>
-          <a:ln>
-            <a:noFill/>
-          </a:ln>
-          <a:effectLst/>
-        </p:spPr>
-        <p:style>
-          <a:lnRef idx="1">
-            <a:schemeClr val="accent1"/>
-          </a:lnRef>
-          <a:fillRef idx="3">
-            <a:schemeClr val="accent1"/>
-          </a:fillRef>
-          <a:effectRef idx="2">
-            <a:schemeClr val="accent1"/>
-          </a:effectRef>
-          <a:fontRef idx="minor">
-            <a:schemeClr val="lt1"/>
-          </a:fontRef>
-        </p:style>
-        <p:txBody>
-          <a:bodyPr rtlCol="0" anchor="ctr"/>
-          <a:lstStyle/>
-          <a:p>
-            <a:pPr algn="ctr"/>
-          </a:p>
-        </p:txBody>
-      </p:sp>
-      <p:sp>
-        <p:nvSpPr>
-          <p:cNvPr id="51" name="Oval 50"/>
-          <p:cNvSpPr/>
-          <p:nvPr/>
-        </p:nvSpPr>
-        <p:spPr>
-          <a:xfrm>
-            <a:off x="1441977" y="4250656"/>
-            <a:ext cx="27432" cy="27432"/>
-          </a:xfrm>
-          <a:prstGeom prst="ellipse">
-            <a:avLst/>
-          </a:prstGeom>
-          <a:solidFill>
-            <a:srgbClr val="3A4A78"/>
-          </a:solidFill>
-          <a:ln>
-            <a:noFill/>
-          </a:ln>
-          <a:effectLst/>
-        </p:spPr>
-        <p:style>
-          <a:lnRef idx="1">
-            <a:schemeClr val="accent1"/>
-          </a:lnRef>
-          <a:fillRef idx="3">
-            <a:schemeClr val="accent1"/>
-          </a:fillRef>
-          <a:effectRef idx="2">
-            <a:schemeClr val="accent1"/>
-          </a:effectRef>
-          <a:fontRef idx="minor">
-            <a:schemeClr val="lt1"/>
-          </a:fontRef>
-        </p:style>
-        <p:txBody>
-          <a:bodyPr rtlCol="0" anchor="ctr"/>
-          <a:lstStyle/>
-          <a:p>
-            <a:pPr algn="ctr"/>
-          </a:p>
-        </p:txBody>
-      </p:sp>
-      <p:sp>
-        <p:nvSpPr>
-          <p:cNvPr id="52" name="Oval 51"/>
-          <p:cNvSpPr/>
-          <p:nvPr/>
-        </p:nvSpPr>
-        <p:spPr>
-          <a:xfrm>
-            <a:off x="3596587" y="1239730"/>
-            <a:ext cx="27432" cy="27432"/>
-          </a:xfrm>
-          <a:prstGeom prst="ellipse">
-            <a:avLst/>
-          </a:prstGeom>
-          <a:solidFill>
-            <a:srgbClr val="3A4A78"/>
-          </a:solidFill>
-          <a:ln>
-            <a:noFill/>
-          </a:ln>
-          <a:effectLst/>
-        </p:spPr>
-        <p:style>
-          <a:lnRef idx="1">
-            <a:schemeClr val="accent1"/>
-          </a:lnRef>
-          <a:fillRef idx="3">
-            <a:schemeClr val="accent1"/>
-          </a:fillRef>
-          <a:effectRef idx="2">
-            <a:schemeClr val="accent1"/>
-          </a:effectRef>
-          <a:fontRef idx="minor">
-            <a:schemeClr val="lt1"/>
-          </a:fontRef>
-        </p:style>
-        <p:txBody>
-          <a:bodyPr rtlCol="0" anchor="ctr"/>
-          <a:lstStyle/>
-          <a:p>
-            <a:pPr algn="ctr"/>
-          </a:p>
-        </p:txBody>
-      </p:sp>
-      <p:sp>
-        <p:nvSpPr>
-          <p:cNvPr id="53" name="Oval 52"/>
-          <p:cNvSpPr/>
-          <p:nvPr/>
-        </p:nvSpPr>
-        <p:spPr>
-          <a:xfrm>
-            <a:off x="6422150" y="1244172"/>
-            <a:ext cx="27432" cy="27432"/>
-          </a:xfrm>
-          <a:prstGeom prst="ellipse">
-            <a:avLst/>
-          </a:prstGeom>
-          <a:solidFill>
-            <a:srgbClr val="3A4A78"/>
-          </a:solidFill>
-          <a:ln>
-            <a:noFill/>
-          </a:ln>
-          <a:effectLst/>
-        </p:spPr>
-        <p:style>
-          <a:lnRef idx="1">
-            <a:schemeClr val="accent1"/>
-          </a:lnRef>
-          <a:fillRef idx="3">
-            <a:schemeClr val="accent1"/>
-          </a:fillRef>
-          <a:effectRef idx="2">
-            <a:schemeClr val="accent1"/>
-          </a:effectRef>
-          <a:fontRef idx="minor">
-            <a:schemeClr val="lt1"/>
-          </a:fontRef>
-        </p:style>
-        <p:txBody>
-          <a:bodyPr rtlCol="0" anchor="ctr"/>
-          <a:lstStyle/>
-          <a:p>
-            <a:pPr algn="ctr"/>
-          </a:p>
-        </p:txBody>
-      </p:sp>
-      <p:sp>
-        <p:nvSpPr>
-          <p:cNvPr id="54" name="Oval 53"/>
-          <p:cNvSpPr/>
-          <p:nvPr/>
-        </p:nvSpPr>
-        <p:spPr>
-          <a:xfrm>
-            <a:off x="7862036" y="2076006"/>
-            <a:ext cx="41148" cy="41148"/>
-          </a:xfrm>
-          <a:prstGeom prst="ellipse">
-            <a:avLst/>
-          </a:prstGeom>
-          <a:solidFill>
-            <a:srgbClr val="3A4A78"/>
-          </a:solidFill>
-          <a:ln>
-            <a:noFill/>
-          </a:ln>
-          <a:effectLst/>
-        </p:spPr>
-        <p:style>
-          <a:lnRef idx="1">
-            <a:schemeClr val="accent1"/>
-          </a:lnRef>
-          <a:fillRef idx="3">
-            <a:schemeClr val="accent1"/>
-          </a:fillRef>
-          <a:effectRef idx="2">
-            <a:schemeClr val="accent1"/>
-          </a:effectRef>
-          <a:fontRef idx="minor">
-            <a:schemeClr val="lt1"/>
-          </a:fontRef>
-        </p:style>
-        <p:txBody>
-          <a:bodyPr rtlCol="0" anchor="ctr"/>
-          <a:lstStyle/>
-          <a:p>
-            <a:pPr algn="ctr"/>
-          </a:p>
-        </p:txBody>
-      </p:sp>
-      <p:sp>
-        <p:nvSpPr>
-          <p:cNvPr id="55" name="Oval 54"/>
-          <p:cNvSpPr/>
-          <p:nvPr/>
-        </p:nvSpPr>
-        <p:spPr>
-          <a:xfrm>
-            <a:off x="3974575" y="3256316"/>
-            <a:ext cx="18288" cy="18288"/>
-          </a:xfrm>
-          <a:prstGeom prst="ellipse">
-            <a:avLst/>
-          </a:prstGeom>
-          <a:solidFill>
-            <a:srgbClr val="3A4A78"/>
-          </a:solidFill>
-          <a:ln>
-            <a:noFill/>
-          </a:ln>
-          <a:effectLst/>
-        </p:spPr>
-        <p:style>
-          <a:lnRef idx="1">
-            <a:schemeClr val="accent1"/>
-          </a:lnRef>
-          <a:fillRef idx="3">
-            <a:schemeClr val="accent1"/>
-          </a:fillRef>
-          <a:effectRef idx="2">
-            <a:schemeClr val="accent1"/>
-          </a:effectRef>
-          <a:fontRef idx="minor">
-            <a:schemeClr val="lt1"/>
-          </a:fontRef>
-        </p:style>
-        <p:txBody>
-          <a:bodyPr rtlCol="0" anchor="ctr"/>
-          <a:lstStyle/>
-          <a:p>
-            <a:pPr algn="ctr"/>
-          </a:p>
-        </p:txBody>
-      </p:sp>
-      <p:sp>
-        <p:nvSpPr>
-          <p:cNvPr id="56" name="Oval 55"/>
-          <p:cNvSpPr/>
-          <p:nvPr/>
-        </p:nvSpPr>
-        <p:spPr>
-          <a:xfrm>
-            <a:off x="3855439" y="2397616"/>
-            <a:ext cx="18288" cy="18288"/>
-          </a:xfrm>
-          <a:prstGeom prst="ellipse">
-            <a:avLst/>
-          </a:prstGeom>
-          <a:solidFill>
-            <a:srgbClr val="3A4A78"/>
-          </a:solidFill>
-          <a:ln>
-            <a:noFill/>
-          </a:ln>
-          <a:effectLst/>
-        </p:spPr>
-        <p:style>
-          <a:lnRef idx="1">
-            <a:schemeClr val="accent1"/>
-          </a:lnRef>
-          <a:fillRef idx="3">
-            <a:schemeClr val="accent1"/>
-          </a:fillRef>
-          <a:effectRef idx="2">
-            <a:schemeClr val="accent1"/>
-          </a:effectRef>
-          <a:fontRef idx="minor">
-            <a:schemeClr val="lt1"/>
-          </a:fontRef>
-        </p:style>
-        <p:txBody>
-          <a:bodyPr rtlCol="0" anchor="ctr"/>
-          <a:lstStyle/>
-          <a:p>
-            <a:pPr algn="ctr"/>
-          </a:p>
-        </p:txBody>
-      </p:sp>
-      <p:sp>
-        <p:nvSpPr>
-          <p:cNvPr id="57" name="Oval 56"/>
-          <p:cNvSpPr/>
-          <p:nvPr/>
-        </p:nvSpPr>
-        <p:spPr>
-          <a:xfrm>
-            <a:off x="3216858" y="1805847"/>
-            <a:ext cx="41148" cy="41148"/>
-          </a:xfrm>
-          <a:prstGeom prst="ellipse">
-            <a:avLst/>
-          </a:prstGeom>
-          <a:solidFill>
-            <a:srgbClr val="3A4A78"/>
-          </a:solidFill>
-          <a:ln>
-            <a:noFill/>
-          </a:ln>
-          <a:effectLst/>
-        </p:spPr>
-        <p:style>
-          <a:lnRef idx="1">
-            <a:schemeClr val="accent1"/>
-          </a:lnRef>
-          <a:fillRef idx="3">
-            <a:schemeClr val="accent1"/>
-          </a:fillRef>
-          <a:effectRef idx="2">
-            <a:schemeClr val="accent1"/>
-          </a:effectRef>
-          <a:fontRef idx="minor">
-            <a:schemeClr val="lt1"/>
-          </a:fontRef>
-        </p:style>
-        <p:txBody>
-          <a:bodyPr rtlCol="0" anchor="ctr"/>
-          <a:lstStyle/>
-          <a:p>
-            <a:pPr algn="ctr"/>
-          </a:p>
-        </p:txBody>
-      </p:sp>
-      <p:sp>
-        <p:nvSpPr>
-          <p:cNvPr id="58" name="Oval 57"/>
-          <p:cNvSpPr/>
-          <p:nvPr/>
-        </p:nvSpPr>
-        <p:spPr>
-          <a:xfrm>
-            <a:off x="6216403" y="1513748"/>
-            <a:ext cx="41148" cy="41148"/>
-          </a:xfrm>
-          <a:prstGeom prst="ellipse">
-            <a:avLst/>
-          </a:prstGeom>
-          <a:solidFill>
-            <a:srgbClr val="3A4A78"/>
-          </a:solidFill>
-          <a:ln>
-            <a:noFill/>
-          </a:ln>
-          <a:effectLst/>
-        </p:spPr>
-        <p:style>
-          <a:lnRef idx="1">
-            <a:schemeClr val="accent1"/>
-          </a:lnRef>
-          <a:fillRef idx="3">
-            <a:schemeClr val="accent1"/>
-          </a:fillRef>
-          <a:effectRef idx="2">
-            <a:schemeClr val="accent1"/>
-          </a:effectRef>
-          <a:fontRef idx="minor">
-            <a:schemeClr val="lt1"/>
-          </a:fontRef>
-        </p:style>
-        <p:txBody>
-          <a:bodyPr rtlCol="0" anchor="ctr"/>
-          <a:lstStyle/>
-          <a:p>
-            <a:pPr algn="ctr"/>
-          </a:p>
-        </p:txBody>
-      </p:sp>
-      <p:sp>
-        <p:nvSpPr>
-          <p:cNvPr id="59" name="Oval 58"/>
-          <p:cNvSpPr/>
-          <p:nvPr/>
-        </p:nvSpPr>
-        <p:spPr>
-          <a:xfrm>
-            <a:off x="5281361" y="6559891"/>
-            <a:ext cx="18288" cy="18288"/>
-          </a:xfrm>
-          <a:prstGeom prst="ellipse">
-            <a:avLst/>
-          </a:prstGeom>
-          <a:solidFill>
-            <a:srgbClr val="3A4A78"/>
-          </a:solidFill>
-          <a:ln>
-            <a:noFill/>
-          </a:ln>
-          <a:effectLst/>
-        </p:spPr>
-        <p:style>
-          <a:lnRef idx="1">
-            <a:schemeClr val="accent1"/>
-          </a:lnRef>
-          <a:fillRef idx="3">
-            <a:schemeClr val="accent1"/>
-          </a:fillRef>
-          <a:effectRef idx="2">
-            <a:schemeClr val="accent1"/>
-          </a:effectRef>
-          <a:fontRef idx="minor">
-            <a:schemeClr val="lt1"/>
-          </a:fontRef>
-        </p:style>
-        <p:txBody>
-          <a:bodyPr rtlCol="0" anchor="ctr"/>
-          <a:lstStyle/>
-          <a:p>
-            <a:pPr algn="ctr"/>
-          </a:p>
-        </p:txBody>
-      </p:sp>
-      <p:sp>
-        <p:nvSpPr>
-          <p:cNvPr id="60" name="Oval 59"/>
-          <p:cNvSpPr/>
-          <p:nvPr/>
-        </p:nvSpPr>
-        <p:spPr>
-          <a:xfrm>
-            <a:off x="350058" y="1101417"/>
-            <a:ext cx="41148" cy="41148"/>
-          </a:xfrm>
-          <a:prstGeom prst="ellipse">
-            <a:avLst/>
-          </a:prstGeom>
-          <a:solidFill>
-            <a:srgbClr val="3A4A78"/>
-          </a:solidFill>
-          <a:ln>
-            <a:noFill/>
-          </a:ln>
-          <a:effectLst/>
-        </p:spPr>
-        <p:style>
-          <a:lnRef idx="1">
-            <a:schemeClr val="accent1"/>
-          </a:lnRef>
-          <a:fillRef idx="3">
-            <a:schemeClr val="accent1"/>
-          </a:fillRef>
-          <a:effectRef idx="2">
-            <a:schemeClr val="accent1"/>
-          </a:effectRef>
-          <a:fontRef idx="minor">
-            <a:schemeClr val="lt1"/>
-          </a:fontRef>
-        </p:style>
-        <p:txBody>
-          <a:bodyPr rtlCol="0" anchor="ctr"/>
-          <a:lstStyle/>
-          <a:p>
-            <a:pPr algn="ctr"/>
-          </a:p>
-        </p:txBody>
-      </p:sp>
-      <p:sp>
-        <p:nvSpPr>
-          <p:cNvPr id="61" name="Oval 60"/>
-          <p:cNvSpPr/>
-          <p:nvPr/>
-        </p:nvSpPr>
-        <p:spPr>
-          <a:xfrm>
-            <a:off x="11576568" y="3071298"/>
-            <a:ext cx="41148" cy="41148"/>
-          </a:xfrm>
-          <a:prstGeom prst="ellipse">
-            <a:avLst/>
-          </a:prstGeom>
-          <a:solidFill>
-            <a:srgbClr val="3A4A78"/>
-          </a:solidFill>
-          <a:ln>
-            <a:noFill/>
-          </a:ln>
-          <a:effectLst/>
-        </p:spPr>
-        <p:style>
-          <a:lnRef idx="1">
-            <a:schemeClr val="accent1"/>
-          </a:lnRef>
-          <a:fillRef idx="3">
-            <a:schemeClr val="accent1"/>
-          </a:fillRef>
-          <a:effectRef idx="2">
-            <a:schemeClr val="accent1"/>
-          </a:effectRef>
-          <a:fontRef idx="minor">
-            <a:schemeClr val="lt1"/>
-          </a:fontRef>
-        </p:style>
-        <p:txBody>
-          <a:bodyPr rtlCol="0" anchor="ctr"/>
-          <a:lstStyle/>
-          <a:p>
-            <a:pPr algn="ctr"/>
-          </a:p>
-        </p:txBody>
-      </p:sp>
-      <p:sp>
-        <p:nvSpPr>
-          <p:cNvPr id="62" name="Oval 61"/>
-          <p:cNvSpPr/>
-          <p:nvPr/>
-        </p:nvSpPr>
-        <p:spPr>
-          <a:xfrm>
-            <a:off x="8219235" y="3723304"/>
-            <a:ext cx="18288" cy="18288"/>
-          </a:xfrm>
-          <a:prstGeom prst="ellipse">
-            <a:avLst/>
-          </a:prstGeom>
-          <a:solidFill>
-            <a:srgbClr val="3A4A78"/>
-          </a:solidFill>
-          <a:ln>
-            <a:noFill/>
-          </a:ln>
-          <a:effectLst/>
-        </p:spPr>
-        <p:style>
-          <a:lnRef idx="1">
-            <a:schemeClr val="accent1"/>
-          </a:lnRef>
-          <a:fillRef idx="3">
-            <a:schemeClr val="accent1"/>
-          </a:fillRef>
-          <a:effectRef idx="2">
-            <a:schemeClr val="accent1"/>
-          </a:effectRef>
-          <a:fontRef idx="minor">
-            <a:schemeClr val="lt1"/>
-          </a:fontRef>
-        </p:style>
-        <p:txBody>
-          <a:bodyPr rtlCol="0" anchor="ctr"/>
-          <a:lstStyle/>
-          <a:p>
-            <a:pPr algn="ctr"/>
-          </a:p>
-        </p:txBody>
-      </p:sp>
       <p:pic>
         <p:nvPicPr>
-          <p:cNvPr id="63" name="Picture 62" descr="PiFinder.jpg"/>
+          <p:cNvPr id="3" name="Picture 2" descr="PiFinder.jpg"/>
           <p:cNvPicPr>
             <a:picLocks noChangeAspect="1"/>
           </p:cNvPicPr>
@@ -5817,8 +3177,8 @@
         </p:blipFill>
         <p:spPr>
           <a:xfrm>
-            <a:off x="7543800" y="0"/>
-            <a:ext cx="4654296" cy="6858000"/>
+            <a:off x="-1161851" y="0"/>
+            <a:ext cx="13353546" cy="6858000"/>
           </a:xfrm>
           <a:prstGeom prst="rect">
             <a:avLst/>
@@ -5827,58 +3187,152 @@
       </p:pic>
       <p:sp>
         <p:nvSpPr>
-          <p:cNvPr id="64" name="Rectangle 63"/>
-          <p:cNvSpPr/>
-          <p:nvPr/>
-        </p:nvSpPr>
-        <p:spPr>
-          <a:xfrm>
-            <a:off x="6903720" y="0"/>
-            <a:ext cx="822960" cy="6858000"/>
+          <p:cNvPr id="4" name="Rectangle 3"/>
+          <p:cNvSpPr/>
+          <p:nvPr/>
+        </p:nvSpPr>
+        <p:spPr>
+          <a:xfrm>
+            <a:off x="0" y="0"/>
+            <a:ext cx="12191695" cy="6858000"/>
           </a:xfrm>
           <a:prstGeom prst="rect">
             <a:avLst/>
           </a:prstGeom>
           <a:solidFill>
-            <a:srgbClr val="0B1026"/>
-          </a:solidFill>
-          <a:ln>
-            <a:noFill/>
-          </a:ln>
-          <a:effectLst/>
-        </p:spPr>
-        <p:style>
-          <a:lnRef idx="1">
-            <a:schemeClr val="accent1"/>
-          </a:lnRef>
-          <a:fillRef idx="3">
-            <a:schemeClr val="accent1"/>
-          </a:fillRef>
-          <a:effectRef idx="2">
-            <a:schemeClr val="accent1"/>
-          </a:effectRef>
-          <a:fontRef idx="minor">
-            <a:schemeClr val="lt1"/>
-          </a:fontRef>
-        </p:style>
-        <p:txBody>
-          <a:bodyPr rtlCol="0" anchor="ctr"/>
-          <a:lstStyle/>
-          <a:p>
-            <a:pPr algn="ctr"/>
-          </a:p>
-        </p:txBody>
-      </p:sp>
-      <p:sp>
-        <p:nvSpPr>
-          <p:cNvPr id="65" name="TextBox 64"/>
+            <a:srgbClr val="0B1026">
+              <a:alpha val="16000"/>
+            </a:srgbClr>
+          </a:solidFill>
+          <a:ln>
+            <a:noFill/>
+          </a:ln>
+          <a:effectLst/>
+        </p:spPr>
+        <p:style>
+          <a:lnRef idx="1">
+            <a:schemeClr val="accent1"/>
+          </a:lnRef>
+          <a:fillRef idx="3">
+            <a:schemeClr val="accent1"/>
+          </a:fillRef>
+          <a:effectRef idx="2">
+            <a:schemeClr val="accent1"/>
+          </a:effectRef>
+          <a:fontRef idx="minor">
+            <a:schemeClr val="lt1"/>
+          </a:fontRef>
+        </p:style>
+        <p:txBody>
+          <a:bodyPr rtlCol="0" anchor="ctr"/>
+          <a:lstStyle/>
+          <a:p>
+            <a:pPr algn="ctr"/>
+          </a:p>
+        </p:txBody>
+      </p:sp>
+      <p:sp>
+        <p:nvSpPr>
+          <p:cNvPr id="5" name="Rectangle 4"/>
+          <p:cNvSpPr/>
+          <p:nvPr/>
+        </p:nvSpPr>
+        <p:spPr>
+          <a:xfrm>
+            <a:off x="0" y="0"/>
+            <a:ext cx="8778240" cy="6858000"/>
+          </a:xfrm>
+          <a:prstGeom prst="rect">
+            <a:avLst/>
+          </a:prstGeom>
+          <a:solidFill>
+            <a:srgbClr val="0B1026">
+              <a:alpha val="24000"/>
+            </a:srgbClr>
+          </a:solidFill>
+          <a:ln>
+            <a:noFill/>
+          </a:ln>
+          <a:effectLst/>
+        </p:spPr>
+        <p:style>
+          <a:lnRef idx="1">
+            <a:schemeClr val="accent1"/>
+          </a:lnRef>
+          <a:fillRef idx="3">
+            <a:schemeClr val="accent1"/>
+          </a:fillRef>
+          <a:effectRef idx="2">
+            <a:schemeClr val="accent1"/>
+          </a:effectRef>
+          <a:fontRef idx="minor">
+            <a:schemeClr val="lt1"/>
+          </a:fontRef>
+        </p:style>
+        <p:txBody>
+          <a:bodyPr rtlCol="0" anchor="ctr"/>
+          <a:lstStyle/>
+          <a:p>
+            <a:pPr algn="ctr"/>
+          </a:p>
+        </p:txBody>
+      </p:sp>
+      <p:sp>
+        <p:nvSpPr>
+          <p:cNvPr id="6" name="Rectangle 5"/>
+          <p:cNvSpPr/>
+          <p:nvPr/>
+        </p:nvSpPr>
+        <p:spPr>
+          <a:xfrm>
+            <a:off x="0" y="0"/>
+            <a:ext cx="6400800" cy="6858000"/>
+          </a:xfrm>
+          <a:prstGeom prst="rect">
+            <a:avLst/>
+          </a:prstGeom>
+          <a:solidFill>
+            <a:srgbClr val="0B1026">
+              <a:alpha val="26000"/>
+            </a:srgbClr>
+          </a:solidFill>
+          <a:ln>
+            <a:noFill/>
+          </a:ln>
+          <a:effectLst/>
+        </p:spPr>
+        <p:style>
+          <a:lnRef idx="1">
+            <a:schemeClr val="accent1"/>
+          </a:lnRef>
+          <a:fillRef idx="3">
+            <a:schemeClr val="accent1"/>
+          </a:fillRef>
+          <a:effectRef idx="2">
+            <a:schemeClr val="accent1"/>
+          </a:effectRef>
+          <a:fontRef idx="minor">
+            <a:schemeClr val="lt1"/>
+          </a:fontRef>
+        </p:style>
+        <p:txBody>
+          <a:bodyPr rtlCol="0" anchor="ctr"/>
+          <a:lstStyle/>
+          <a:p>
+            <a:pPr algn="ctr"/>
+          </a:p>
+        </p:txBody>
+      </p:sp>
+      <p:sp>
+        <p:nvSpPr>
+          <p:cNvPr id="7" name="TextBox 6"/>
           <p:cNvSpPr txBox="1"/>
           <p:nvPr/>
         </p:nvSpPr>
         <p:spPr>
           <a:xfrm>
-            <a:off x="640080" y="1783080"/>
-            <a:ext cx="6400800" cy="457200"/>
+            <a:off x="640080" y="1325880"/>
+            <a:ext cx="6583680" cy="365760"/>
           </a:xfrm>
           <a:prstGeom prst="rect">
             <a:avLst/>
@@ -5914,7 +3368,7 @@
             <a:r>
               <a:rPr sz="1800" b="1" i="0">
                 <a:solidFill>
-                  <a:srgbClr val="9AA6C2"/>
+                  <a:srgbClr val="EAEFF8"/>
                 </a:solidFill>
                 <a:latin typeface="Calibri"/>
               </a:rPr>
@@ -5934,14 +3388,14 @@
       </p:sp>
       <p:sp>
         <p:nvSpPr>
-          <p:cNvPr id="66" name="TextBox 65"/>
+          <p:cNvPr id="8" name="TextBox 7"/>
           <p:cNvSpPr txBox="1"/>
           <p:nvPr/>
         </p:nvSpPr>
         <p:spPr>
           <a:xfrm>
-            <a:off x="640080" y="2286000"/>
-            <a:ext cx="6126480" cy="2194560"/>
+            <a:off x="640080" y="1783080"/>
+            <a:ext cx="6583680" cy="2103120"/>
           </a:xfrm>
           <a:prstGeom prst="rect">
             <a:avLst/>
@@ -5966,7 +3420,7 @@
               </a:spcAft>
             </a:pPr>
             <a:r>
-              <a:rPr sz="3800" b="1" i="0">
+              <a:rPr sz="3900" b="1" i="0">
                 <a:solidFill>
                   <a:srgbClr val="FFFFFF"/>
                 </a:solidFill>
@@ -5988,7 +3442,7 @@
               </a:spcAft>
             </a:pPr>
             <a:r>
-              <a:rPr sz="3800" b="1" i="0">
+              <a:rPr sz="3900" b="1" i="0">
                 <a:solidFill>
                   <a:srgbClr val="FFFFFF"/>
                 </a:solidFill>
@@ -6001,14 +3455,14 @@
       </p:sp>
       <p:sp>
         <p:nvSpPr>
-          <p:cNvPr id="67" name="TextBox 66"/>
+          <p:cNvPr id="9" name="TextBox 8"/>
           <p:cNvSpPr txBox="1"/>
           <p:nvPr/>
         </p:nvSpPr>
         <p:spPr>
           <a:xfrm>
-            <a:off x="640080" y="4160520"/>
-            <a:ext cx="5852160" cy="1097280"/>
+            <a:off x="640080" y="3703320"/>
+            <a:ext cx="6035040" cy="1097280"/>
           </a:xfrm>
           <a:prstGeom prst="rect">
             <a:avLst/>
@@ -6033,26 +3487,26 @@
               </a:spcAft>
             </a:pPr>
             <a:r>
-              <a:rPr sz="2100" b="0" i="0">
-                <a:solidFill>
-                  <a:srgbClr val="9AA6C2"/>
+              <a:rPr sz="2000" b="0" i="0">
+                <a:solidFill>
+                  <a:srgbClr val="EAEFF8"/>
                 </a:solidFill>
                 <a:latin typeface="Calibri"/>
               </a:rPr>
-              <a:t>One Raspberry Pi. PiFinder answers “where am I pointing”, StellarMate drives everything else — joined over INDI.</a:t>
-            </a:r>
-          </a:p>
-        </p:txBody>
-      </p:sp>
-      <p:sp>
-        <p:nvSpPr>
-          <p:cNvPr id="68" name="TextBox 67"/>
+              <a:t>One Raspberry Pi. PiFinder answers “where am I pointing”; StellarMate drives the rest — over INDI.</a:t>
+            </a:r>
+          </a:p>
+        </p:txBody>
+      </p:sp>
+      <p:sp>
+        <p:nvSpPr>
+          <p:cNvPr id="10" name="TextBox 9"/>
           <p:cNvSpPr txBox="1"/>
           <p:nvPr/>
         </p:nvSpPr>
         <p:spPr>
           <a:xfrm>
-            <a:off x="640080" y="5989320"/>
+            <a:off x="640080" y="4983480"/>
             <a:ext cx="6400800" cy="320040"/>
           </a:xfrm>
           <a:prstGeom prst="rect">
@@ -6091,14 +3545,14 @@
       </p:sp>
       <p:sp>
         <p:nvSpPr>
-          <p:cNvPr id="69" name="TextBox 68"/>
+          <p:cNvPr id="11" name="TextBox 10"/>
           <p:cNvSpPr txBox="1"/>
           <p:nvPr/>
         </p:nvSpPr>
         <p:spPr>
           <a:xfrm>
-            <a:off x="640080" y="6309360"/>
-            <a:ext cx="6400800" cy="274320"/>
+            <a:off x="640080" y="5321808"/>
+            <a:ext cx="6949440" cy="274320"/>
           </a:xfrm>
           <a:prstGeom prst="rect">
             <a:avLst/>
@@ -6125,7 +3579,7 @@
             <a:r>
               <a:rPr sz="1200" b="0" i="0">
                 <a:solidFill>
-                  <a:srgbClr val="5C677B"/>
+                  <a:srgbClr val="C2CBDB"/>
                 </a:solidFill>
                 <a:latin typeface="Calibri"/>
               </a:rPr>
@@ -9008,8 +6462,8 @@
         </p:nvSpPr>
         <p:spPr>
           <a:xfrm>
-            <a:off x="640080" y="2103120"/>
-            <a:ext cx="6766560" cy="3657600"/>
+            <a:off x="640080" y="2148840"/>
+            <a:ext cx="5943600" cy="3840480"/>
           </a:xfrm>
           <a:prstGeom prst="rect">
             <a:avLst/>
@@ -9030,7 +6484,7 @@
                 <a:spcPts val="0"/>
               </a:spcBef>
               <a:spcAft>
-                <a:spcPts val="1800"/>
+                <a:spcPts val="2000"/>
               </a:spcAft>
             </a:pPr>
             <a:r>
@@ -9061,7 +6515,7 @@
                 <a:spcPts val="0"/>
               </a:spcBef>
               <a:spcAft>
-                <a:spcPts val="1800"/>
+                <a:spcPts val="2000"/>
               </a:spcAft>
             </a:pPr>
             <a:r>
@@ -9092,7 +6546,7 @@
                 <a:spcPts val="0"/>
               </a:spcBef>
               <a:spcAft>
-                <a:spcPts val="1800"/>
+                <a:spcPts val="2000"/>
               </a:spcAft>
             </a:pPr>
             <a:r>
@@ -9123,7 +6577,7 @@
                 <a:spcPts val="0"/>
               </a:spcBef>
               <a:spcAft>
-                <a:spcPts val="1800"/>
+                <a:spcPts val="2000"/>
               </a:spcAft>
             </a:pPr>
             <a:r>
@@ -9163,8 +6617,8 @@
         </p:blipFill>
         <p:spPr>
           <a:xfrm>
-            <a:off x="8366760" y="822960"/>
-            <a:ext cx="3383280" cy="4271391"/>
+            <a:off x="6796735" y="225456"/>
+            <a:ext cx="5074920" cy="6407086"/>
           </a:xfrm>
           <a:prstGeom prst="rect">
             <a:avLst/>
@@ -9433,7 +6887,7 @@
         <p:spPr>
           <a:xfrm>
             <a:off x="640080" y="2194560"/>
-            <a:ext cx="6949440" cy="2194560"/>
+            <a:ext cx="5943600" cy="2743200"/>
           </a:xfrm>
           <a:prstGeom prst="rect">
             <a:avLst/>
@@ -9477,8 +6931,8 @@
         </p:nvSpPr>
         <p:spPr>
           <a:xfrm>
-            <a:off x="640080" y="4206240"/>
-            <a:ext cx="6949440" cy="2011680"/>
+            <a:off x="640080" y="4572000"/>
+            <a:ext cx="5943600" cy="1828800"/>
           </a:xfrm>
           <a:prstGeom prst="rect">
             <a:avLst/>
@@ -9570,8 +7024,8 @@
         </p:blipFill>
         <p:spPr>
           <a:xfrm>
-            <a:off x="8366760" y="822960"/>
-            <a:ext cx="3383280" cy="4271391"/>
+            <a:off x="6796735" y="225456"/>
+            <a:ext cx="5074920" cy="6407086"/>
           </a:xfrm>
           <a:prstGeom prst="rect">
             <a:avLst/>
@@ -10517,8 +7971,8 @@
         </p:nvSpPr>
         <p:spPr>
           <a:xfrm>
-            <a:off x="640080" y="2103120"/>
-            <a:ext cx="6035040" cy="3840480"/>
+            <a:off x="640080" y="2331720"/>
+            <a:ext cx="4114800" cy="3840480"/>
           </a:xfrm>
           <a:prstGeom prst="rect">
             <a:avLst/>
@@ -10539,7 +7993,7 @@
                 <a:spcPts val="0"/>
               </a:spcBef>
               <a:spcAft>
-                <a:spcPts val="1600"/>
+                <a:spcPts val="2400"/>
               </a:spcAft>
             </a:pPr>
             <a:r>
@@ -10552,22 +8006,13 @@
               <a:t>▸  </a:t>
             </a:r>
             <a:r>
-              <a:rPr sz="2100" b="1" i="0">
+              <a:rPr sz="2100" b="0" i="0">
                 <a:solidFill>
                   <a:srgbClr val="182030"/>
                 </a:solidFill>
                 <a:latin typeface="Calibri"/>
               </a:rPr>
-              <a:t>Quick Actions </a:t>
-            </a:r>
-            <a:r>
-              <a:rPr sz="2100" b="0" i="0">
-                <a:solidFill>
-                  <a:srgbClr val="182030"/>
-                </a:solidFill>
-                <a:latin typeface="Calibri"/>
-              </a:rPr>
-              <a:t>— Sync from PiFinder, Goto Held Target, Stop.</a:t>
+              <a:t>Quick Actions — one-shots</a:t>
             </a:r>
           </a:p>
           <a:p>
@@ -10579,7 +8024,7 @@
                 <a:spcPts val="0"/>
               </a:spcBef>
               <a:spcAft>
-                <a:spcPts val="1600"/>
+                <a:spcPts val="2400"/>
               </a:spcAft>
             </a:pPr>
             <a:r>
@@ -10592,22 +8037,13 @@
               <a:t>▸  </a:t>
             </a:r>
             <a:r>
-              <a:rPr sz="2100" b="1" i="0">
+              <a:rPr sz="2100" b="0" i="0">
                 <a:solidFill>
                   <a:srgbClr val="182030"/>
                 </a:solidFill>
                 <a:latin typeface="Calibri"/>
               </a:rPr>
-              <a:t>Coupling presets </a:t>
-            </a:r>
-            <a:r>
-              <a:rPr sz="2100" b="0" i="0">
-                <a:solidFill>
-                  <a:srgbClr val="182030"/>
-                </a:solidFill>
-                <a:latin typeface="Calibri"/>
-              </a:rPr>
-              <a:t>— one click sets every INDI property.</a:t>
+              <a:t>Coupling presets — one click</a:t>
             </a:r>
           </a:p>
           <a:p>
@@ -10619,7 +8055,7 @@
                 <a:spcPts val="0"/>
               </a:spcBef>
               <a:spcAft>
-                <a:spcPts val="1600"/>
+                <a:spcPts val="2400"/>
               </a:spcAft>
             </a:pPr>
             <a:r>
@@ -10632,22 +8068,13 @@
               <a:t>▸  </a:t>
             </a:r>
             <a:r>
-              <a:rPr sz="2100" b="1" i="0">
+              <a:rPr sz="2100" b="0" i="0">
                 <a:solidFill>
                   <a:srgbClr val="182030"/>
                 </a:solidFill>
                 <a:latin typeface="Calibri"/>
               </a:rPr>
-              <a:t>Settings </a:t>
-            </a:r>
-            <a:r>
-              <a:rPr sz="2100" b="0" i="0">
-                <a:solidFill>
-                  <a:srgbClr val="182030"/>
-                </a:solidFill>
-                <a:latin typeface="Calibri"/>
-              </a:rPr>
-              <a:t>— one-time setup, collapsed away.</a:t>
+              <a:t>Settings — set once, hidden</a:t>
             </a:r>
           </a:p>
         </p:txBody>
@@ -10668,8 +8095,8 @@
         </p:blipFill>
         <p:spPr>
           <a:xfrm>
-            <a:off x="7315200" y="1463040"/>
-            <a:ext cx="4572000" cy="3546054"/>
+            <a:off x="4797927" y="685800"/>
+            <a:ext cx="7073727" cy="5486400"/>
           </a:xfrm>
           <a:prstGeom prst="rect">
             <a:avLst/>

</xml_diff>